<commit_message>
Trim pitch copy and simplify closing slide
</commit_message>
<xml_diff>
--- a/docs/Fairtix-pitch.pptx
+++ b/docs/Fairtix-pitch.pptx
@@ -2,20 +2,20 @@
 <file path=ppt/presentation.xml><?xml version="1.0" encoding="utf-8"?>
 <p:presentation xmlns:p="http://schemas.openxmlformats.org/presentationml/2006/main">
   <p:sldMasterIdLst>
-    <p:sldMasterId xmlns:r="http://schemas.openxmlformats.org/officeDocument/2006/relationships" id="2147483648" r:id="R357de8d95e0a45e7"/>
+    <p:sldMasterId xmlns:r="http://schemas.openxmlformats.org/officeDocument/2006/relationships" id="2147483648" r:id="R8ca0deebbda3436d"/>
   </p:sldMasterIdLst>
   <p:notesMasterIdLst>
-    <p:notesMasterId xmlns:r="http://schemas.openxmlformats.org/officeDocument/2006/relationships" r:id="Re1093ca0470d4998"/>
+    <p:notesMasterId xmlns:r="http://schemas.openxmlformats.org/officeDocument/2006/relationships" r:id="R2bdaa6e8d5454cdc"/>
   </p:notesMasterIdLst>
   <p:sldIdLst>
-    <p:sldId xmlns:r="http://schemas.openxmlformats.org/officeDocument/2006/relationships" id="256" r:id="R54b23e2aa5d641fa"/>
-    <p:sldId xmlns:r="http://schemas.openxmlformats.org/officeDocument/2006/relationships" id="257" r:id="Rf285dd14cf814a2f"/>
-    <p:sldId xmlns:r="http://schemas.openxmlformats.org/officeDocument/2006/relationships" id="258" r:id="R922c57cac2e249b6"/>
-    <p:sldId xmlns:r="http://schemas.openxmlformats.org/officeDocument/2006/relationships" id="259" r:id="R0c404d7ccc13416e"/>
-    <p:sldId xmlns:r="http://schemas.openxmlformats.org/officeDocument/2006/relationships" id="260" r:id="Ra5d1e2a68daf4bb5"/>
-    <p:sldId xmlns:r="http://schemas.openxmlformats.org/officeDocument/2006/relationships" id="261" r:id="R84d74a3e86bc428d"/>
-    <p:sldId xmlns:r="http://schemas.openxmlformats.org/officeDocument/2006/relationships" id="262" r:id="R606c9fa51bf74219"/>
-    <p:sldId xmlns:r="http://schemas.openxmlformats.org/officeDocument/2006/relationships" id="263" r:id="R61f7d8638034465e"/>
+    <p:sldId xmlns:r="http://schemas.openxmlformats.org/officeDocument/2006/relationships" id="256" r:id="Raa040adbecb64c8b"/>
+    <p:sldId xmlns:r="http://schemas.openxmlformats.org/officeDocument/2006/relationships" id="257" r:id="Rdd7b9a347c5b4e21"/>
+    <p:sldId xmlns:r="http://schemas.openxmlformats.org/officeDocument/2006/relationships" id="258" r:id="R0e9cab061f9648ae"/>
+    <p:sldId xmlns:r="http://schemas.openxmlformats.org/officeDocument/2006/relationships" id="259" r:id="R28ebf15047894d08"/>
+    <p:sldId xmlns:r="http://schemas.openxmlformats.org/officeDocument/2006/relationships" id="260" r:id="Rc2e06357ecee46cb"/>
+    <p:sldId xmlns:r="http://schemas.openxmlformats.org/officeDocument/2006/relationships" id="261" r:id="Rcaddc44b85374020"/>
+    <p:sldId xmlns:r="http://schemas.openxmlformats.org/officeDocument/2006/relationships" id="262" r:id="R567ab4779bd544d0"/>
+    <p:sldId xmlns:r="http://schemas.openxmlformats.org/officeDocument/2006/relationships" id="263" r:id="R0c997fc7f0da42f4"/>
   </p:sldIdLst>
   <p:sldSz cx="12192000" cy="6858000"/>
   <p:notesSz cx="6858000" cy="9144000"/>
@@ -449,7 +449,7 @@
           <a:lstStyle xmlns:a="http://schemas.openxmlformats.org/drawingml/2006/main"/>
           <a:p xmlns:a="http://schemas.openxmlformats.org/drawingml/2006/main">
             <a:r>
-              <a:t>Fairtix is a working ticketing prototype on Solana devnet. An organizer chooses the maximum recorded resale price. Fans buy and resell tickets. Product scope: general admission. Source: https://github.com/rmazz05/fairtix/blob/0175ebf9f62bee79187c1c6dc2ff0de716cc455c/chain/programs/fairtix_market/src/lib.rs and https://github.com/rmazz05/fairtix/blob/0175ebf9f62bee79187c1c6dc2ff0de716cc455c/chain/programs/fairtix_hook/src/lib.rs. No organizer adoption, paid customers or real-money checkout is claimed.</a:t>
+              <a:t>Fairtix lets organizers set a ticket resale cap. Sources: https://github.com/rmazz05/fairtix/blob/0175ebf9f62bee79187c1c6dc2ff0de716cc455c/chain/programs/fairtix_market/src/lib.rs; https://github.com/rmazz05/fairtix/blob/0175ebf9f62bee79187c1c6dc2ff0de716cc455c/chain/programs/fairtix_hook/src/lib.rs.</a:t>
             </a:r>
           </a:p>
         </p:txBody>
@@ -519,7 +519,7 @@
           <a:lstStyle xmlns:a="http://schemas.openxmlformats.org/drawingml/2006/main"/>
           <a:p xmlns:a="http://schemas.openxmlformats.org/drawingml/2006/main">
             <a:r>
-              <a:t>The problem statement is supplied by the project owner. This is a description of the direct-transfer loophole, not a market statistic or a claim that every ticketing service works this way. The €25 and €60 prices are the demonstration scenario.</a:t>
+              <a:t>A transferable ticket can change hands after payment elsewhere. Illustrative scenario: €25 original price, €60 resale asking price.</a:t>
             </a:r>
           </a:p>
         </p:txBody>
@@ -799,7 +799,7 @@
           <a:lstStyle xmlns:a="http://schemas.openxmlformats.org/drawingml/2006/main"/>
           <a:p xmlns:a="http://schemas.openxmlformats.org/drawingml/2006/main">
             <a:r>
-              <a:t>The image is a genuine Fairtix public devnet browser capture, cropped to the test interaction. It is not a mockup. The receipt links show transactions on devnet through the current code, whose statuses were checked finalized on 2 October 2026. €60 above-cap listing: https://explorer.solana.com/tx/2iXm5UigJ2JhgtFj8yDqRdpwgQGuDVEGxVgZW52y2Hds9vF3jhjQh3C5neMySk6dX7r9odjrbaGSTC66Qypxpcwu?cluster=devnet. Signed direct transfer: https://explorer.solana.com/tx/33GCbYNPFE7EBGggbLqErzKvDja1mKzhwW3H9E3dP9PbQdiUucWDdHvkiNRHNyFmbzFKSinaWBWZa6onXeVMBQUU?cluster=devnet. Successful €27.50 resale: https://explorer.solana.com/tx/3FYCU8uRkaFYN1YuDtE8dA1QbjDjoguZj67NMZHvXiAzG9riQh86aZpVQMPcUwV8pRgHpceuN2WuKJfaLgSVEzQb?cluster=devnet. The application additionally records failed attempts for the organizer. Network: devnet. All prices are test credits. Source: docs/browser-verification.md.</a:t>
+              <a:t>Screenshot: docs/screenshots/public-devnet-over-cap.jpg. Solana devnet transactions, using test credits: €60 above-cap listing https://explorer.solana.com/tx/2iXm5UigJ2JhgtFj8yDqRdpwgQGuDVEGxVgZW52y2Hds9vF3jhjQh3C5neMySk6dX7r9odjrbaGSTC66Qypxpcwu?cluster=devnet; signed direct transfer https://explorer.solana.com/tx/33GCbYNPFE7EBGggbLqErzKvDja1mKzhwW3H9E3dP9PbQdiUucWDdHvkiNRHNyFmbzFKSinaWBWZa6onXeVMBQUU?cluster=devnet; successful €27.50 resale https://explorer.solana.com/tx/3FYCU8uRkaFYN1YuDtE8dA1QbjDjoguZj67NMZHvXiAzG9riQh86aZpVQMPcUwV8pRgHpceuN2WuKJfaLgSVEzQb?cluster=devnet.</a:t>
             </a:r>
           </a:p>
         </p:txBody>
@@ -939,7 +939,7 @@
           <a:lstStyle xmlns:a="http://schemas.openxmlformats.org/drawingml/2006/main"/>
           <a:p xmlns:a="http://schemas.openxmlformats.org/drawingml/2006/main">
             <a:r>
-              <a:t>Public demo: https://fairtix-whu.vercel.app/demo. The guide lets a reviewer use a seller and buyer in the same browser without email or a browser wallet. The public deployment also supports Privy email sign-in, previously confirmed by the owner. Current limits: token test credits only; no actual euro payments, entry, check-in, identity verification or mainnet. The program checks the recorded resale price. Cash side payments and wallet/private-key sharing remain possible. Development upgrade authority remains active. Independent security review has not been completed. No pilot commitments, customers or adoption statistics are claimed.</a:t>
+              <a:t>Public demo: https://fairtix-whu.vercel.app/demo.</a:t>
             </a:r>
           </a:p>
         </p:txBody>
@@ -1007,7 +1007,7 @@
   </p:cSld>
   <p:clrMap bg1="lt1" tx1="dk1" bg2="lt2" tx2="dk2" accent1="accent1" accent2="accent2" accent3="accent3" accent4="accent4" accent5="accent5" accent6="accent6" hlink="hlink" folHlink="folHlink"/>
   <p:sldLayoutIdLst>
-    <p:sldLayoutId xmlns:r="http://schemas.openxmlformats.org/officeDocument/2006/relationships" id="2147483649" r:id="Ra7e76e8d59dc4b14"/>
+    <p:sldLayoutId xmlns:r="http://schemas.openxmlformats.org/officeDocument/2006/relationships" id="2147483649" r:id="R110745459dcf4bfa"/>
   </p:sldLayoutIdLst>
   <p:txStyles>
     <p:titleStyle>
@@ -1555,10 +1555,10 @@
       </p:grpSpPr>
       <p:sp>
         <p:nvSpPr>
-          <p:cNvPr id="8" name="text-1-0">
-            <a:extLst xmlns:a="http://schemas.openxmlformats.org/drawingml/2006/main">
-              <a:ext uri="{FF2B5EF4-FFF2-40B4-BE49-F238E27FC236}">
-                <a16:creationId xmlns:a16="http://schemas.microsoft.com/office/drawing/2014/main" id="{671C9AB6-359D-44F1-AA8A-A633C6E8E132}"/>
+          <p:cNvPr id="7" name="text-1-0">
+            <a:extLst xmlns:a="http://schemas.openxmlformats.org/drawingml/2006/main">
+              <a:ext uri="{FF2B5EF4-FFF2-40B4-BE49-F238E27FC236}">
+                <a16:creationId xmlns:a16="http://schemas.microsoft.com/office/drawing/2014/main" id="{86040306-AF22-483A-8394-5E02B1872676}"/>
               </a:ext>
             </a:extLst>
           </p:cNvPr>
@@ -1615,7 +1615,7 @@
           <p:cNvPr id="2" name="text-1-1">
             <a:extLst xmlns:a="http://schemas.openxmlformats.org/drawingml/2006/main">
               <a:ext uri="{FF2B5EF4-FFF2-40B4-BE49-F238E27FC236}">
-                <a16:creationId xmlns:a16="http://schemas.microsoft.com/office/drawing/2014/main" id="{E1E3487E-B209-4FEA-8F44-BBAF05467406}"/>
+                <a16:creationId xmlns:a16="http://schemas.microsoft.com/office/drawing/2014/main" id="{94DDBD1D-9B63-46B7-8A29-CA349EF4B979}"/>
               </a:ext>
             </a:extLst>
           </p:cNvPr>
@@ -1672,7 +1672,7 @@
           <p:cNvPr id="3" name="text-1-2">
             <a:extLst xmlns:a="http://schemas.openxmlformats.org/drawingml/2006/main">
               <a:ext uri="{FF2B5EF4-FFF2-40B4-BE49-F238E27FC236}">
-                <a16:creationId xmlns:a16="http://schemas.microsoft.com/office/drawing/2014/main" id="{B1D1548C-09A2-4D40-BF9C-0DDE2D9DDBBE}"/>
+                <a16:creationId xmlns:a16="http://schemas.microsoft.com/office/drawing/2014/main" id="{20FCD803-6556-472F-9202-285C40516EE2}"/>
               </a:ext>
             </a:extLst>
           </p:cNvPr>
@@ -1729,7 +1729,7 @@
           <p:cNvPr id="4" name="text-1-3">
             <a:extLst xmlns:a="http://schemas.openxmlformats.org/drawingml/2006/main">
               <a:ext uri="{FF2B5EF4-FFF2-40B4-BE49-F238E27FC236}">
-                <a16:creationId xmlns:a16="http://schemas.microsoft.com/office/drawing/2014/main" id="{04DF7E40-4AA3-4987-B3DB-6C64FBAA1DED}"/>
+                <a16:creationId xmlns:a16="http://schemas.microsoft.com/office/drawing/2014/main" id="{9CEB75E9-7C30-45BC-A614-EB36A427A12C}"/>
               </a:ext>
             </a:extLst>
           </p:cNvPr>
@@ -1786,7 +1786,7 @@
           <p:cNvPr id="5" name="text-1-4">
             <a:extLst xmlns:a="http://schemas.openxmlformats.org/drawingml/2006/main">
               <a:ext uri="{FF2B5EF4-FFF2-40B4-BE49-F238E27FC236}">
-                <a16:creationId xmlns:a16="http://schemas.microsoft.com/office/drawing/2014/main" id="{608AF3EC-DA47-4946-9936-EEBE8477196E}"/>
+                <a16:creationId xmlns:a16="http://schemas.microsoft.com/office/drawing/2014/main" id="{8CAD1203-29C9-413F-8A91-A40BAE7BFD7C}"/>
               </a:ext>
             </a:extLst>
           </p:cNvPr>
@@ -1843,7 +1843,7 @@
           <p:cNvPr id="6" name="text-1-5">
             <a:extLst xmlns:a="http://schemas.openxmlformats.org/drawingml/2006/main">
               <a:ext uri="{FF2B5EF4-FFF2-40B4-BE49-F238E27FC236}">
-                <a16:creationId xmlns:a16="http://schemas.microsoft.com/office/drawing/2014/main" id="{6DCAAD63-E3CB-4B54-8946-3A6A2A50513A}"/>
+                <a16:creationId xmlns:a16="http://schemas.microsoft.com/office/drawing/2014/main" id="{10EC48C8-733B-4599-90F6-17BBB40FFB7F}"/>
               </a:ext>
             </a:extLst>
           </p:cNvPr>
@@ -1891,63 +1891,6 @@
                 <a:cs typeface="IBM Plex Sans"/>
               </a:rPr>
               <a:t>The organizer decides the maximum price.</a:t>
-            </a:r>
-          </a:p>
-        </p:txBody>
-      </p:sp>
-      <p:sp>
-        <p:nvSpPr>
-          <p:cNvPr id="7" name="text-1-6">
-            <a:extLst xmlns:a="http://schemas.openxmlformats.org/drawingml/2006/main">
-              <a:ext uri="{FF2B5EF4-FFF2-40B4-BE49-F238E27FC236}">
-                <a16:creationId xmlns:a16="http://schemas.microsoft.com/office/drawing/2014/main" id="{81134C3E-38F6-4F44-8D63-BF611F41D72F}"/>
-              </a:ext>
-            </a:extLst>
-          </p:cNvPr>
-          <p:cNvSpPr>
-            <a:spLocks xmlns:a="http://schemas.openxmlformats.org/drawingml/2006/main" noGrp="1"/>
-          </p:cNvSpPr>
-          <p:nvPr/>
-        </p:nvSpPr>
-        <p:spPr>
-          <a:xfrm xmlns:a="http://schemas.openxmlformats.org/drawingml/2006/main">
-            <a:off x="685800" y="5962650"/>
-            <a:ext cx="9715500" cy="324612"/>
-          </a:xfrm>
-          <a:prstGeom xmlns:a="http://schemas.openxmlformats.org/drawingml/2006/main" prst="rect">
-            <a:avLst/>
-          </a:prstGeom>
-          <a:noFill xmlns:a="http://schemas.openxmlformats.org/drawingml/2006/main"/>
-          <a:ln xmlns:a="http://schemas.openxmlformats.org/drawingml/2006/main" w="0">
-            <a:noFill/>
-          </a:ln>
-        </p:spPr>
-        <p:txBody>
-          <a:bodyPr xmlns:a="http://schemas.openxmlformats.org/drawingml/2006/main" wrap="none" lIns="0" tIns="0" rIns="0" bIns="0" anchor="t">
-            <a:noAutofit/>
-          </a:bodyPr>
-          <a:lstStyle xmlns:a="http://schemas.openxmlformats.org/drawingml/2006/main"/>
-          <a:p xmlns:a="http://schemas.openxmlformats.org/drawingml/2006/main">
-            <a:pPr>
-              <a:defRPr sz="1800" b="0">
-                <a:solidFill>
-                  <a:srgbClr val="5B554C"/>
-                </a:solidFill>
-                <a:latin typeface="IBM Plex Sans"/>
-                <a:ea typeface="IBM Plex Sans"/>
-                <a:cs typeface="IBM Plex Sans"/>
-              </a:defRPr>
-            </a:pPr>
-            <a:r>
-              <a:rPr sz="1800" b="0">
-                <a:solidFill>
-                  <a:srgbClr val="5B554C"/>
-                </a:solidFill>
-                <a:latin typeface="IBM Plex Sans"/>
-                <a:ea typeface="IBM Plex Sans"/>
-                <a:cs typeface="IBM Plex Sans"/>
-              </a:rPr>
-              <a:t>Working prototype on Solana devnet</a:t>
             </a:r>
           </a:p>
         </p:txBody>
@@ -1955,7 +1898,7 @@
     </p:spTree>
     <p:extLst>
       <p:ext uri="{BB962C8B-B14F-4D97-AF65-F5344CB8AC3E}">
-        <p14:creationId xmlns:p14="http://schemas.microsoft.com/office/powerpoint/2010/main" val="1775468428"/>
+        <p14:creationId xmlns:p14="http://schemas.microsoft.com/office/powerpoint/2010/main" val="320222409"/>
       </p:ext>
     </p:extLst>
   </p:cSld>
@@ -1986,7 +1929,7 @@
           <p:cNvPr id="11" name="text-2-0">
             <a:extLst xmlns:a="http://schemas.openxmlformats.org/drawingml/2006/main">
               <a:ext uri="{FF2B5EF4-FFF2-40B4-BE49-F238E27FC236}">
-                <a16:creationId xmlns:a16="http://schemas.microsoft.com/office/drawing/2014/main" id="{6E0B1AFE-78E4-486B-88AD-2CE74070F53D}"/>
+                <a16:creationId xmlns:a16="http://schemas.microsoft.com/office/drawing/2014/main" id="{348C55AD-00EC-4121-8196-DDB91CE7C960}"/>
               </a:ext>
             </a:extLst>
           </p:cNvPr>
@@ -2043,7 +1986,7 @@
           <p:cNvPr id="2" name="text-2-1">
             <a:extLst xmlns:a="http://schemas.openxmlformats.org/drawingml/2006/main">
               <a:ext uri="{FF2B5EF4-FFF2-40B4-BE49-F238E27FC236}">
-                <a16:creationId xmlns:a16="http://schemas.microsoft.com/office/drawing/2014/main" id="{1C3903B1-3AD4-4FA7-B416-DFBD71427730}"/>
+                <a16:creationId xmlns:a16="http://schemas.microsoft.com/office/drawing/2014/main" id="{52AC42EE-A4A4-4F65-8529-AC5F9AC61074}"/>
               </a:ext>
             </a:extLst>
           </p:cNvPr>
@@ -2100,7 +2043,7 @@
           <p:cNvPr id="3" name="text-2-2">
             <a:extLst xmlns:a="http://schemas.openxmlformats.org/drawingml/2006/main">
               <a:ext uri="{FF2B5EF4-FFF2-40B4-BE49-F238E27FC236}">
-                <a16:creationId xmlns:a16="http://schemas.microsoft.com/office/drawing/2014/main" id="{05616E1A-AF6B-42F8-815F-82756E3C2989}"/>
+                <a16:creationId xmlns:a16="http://schemas.microsoft.com/office/drawing/2014/main" id="{D2FDD528-C99A-49A8-B977-546F28F23822}"/>
               </a:ext>
             </a:extLst>
           </p:cNvPr>
@@ -2157,7 +2100,7 @@
           <p:cNvPr id="4" name="text-2-3">
             <a:extLst xmlns:a="http://schemas.openxmlformats.org/drawingml/2006/main">
               <a:ext uri="{FF2B5EF4-FFF2-40B4-BE49-F238E27FC236}">
-                <a16:creationId xmlns:a16="http://schemas.microsoft.com/office/drawing/2014/main" id="{4FFF289E-71BB-48C1-AC86-A97F2DBC6DFF}"/>
+                <a16:creationId xmlns:a16="http://schemas.microsoft.com/office/drawing/2014/main" id="{8CDCCA5C-BC2E-4951-B2A0-DA2EE3FBAED0}"/>
               </a:ext>
             </a:extLst>
           </p:cNvPr>
@@ -2214,7 +2157,7 @@
           <p:cNvPr id="5" name="text-2-4">
             <a:extLst xmlns:a="http://schemas.openxmlformats.org/drawingml/2006/main">
               <a:ext uri="{FF2B5EF4-FFF2-40B4-BE49-F238E27FC236}">
-                <a16:creationId xmlns:a16="http://schemas.microsoft.com/office/drawing/2014/main" id="{B51C7FEB-9813-4C9E-B7C4-6A482D4277FA}"/>
+                <a16:creationId xmlns:a16="http://schemas.microsoft.com/office/drawing/2014/main" id="{D0EE50F0-D199-4050-AB3B-190EB3959650}"/>
               </a:ext>
             </a:extLst>
           </p:cNvPr>
@@ -2271,7 +2214,7 @@
           <p:cNvPr id="6" name="text-2-5">
             <a:extLst xmlns:a="http://schemas.openxmlformats.org/drawingml/2006/main">
               <a:ext uri="{FF2B5EF4-FFF2-40B4-BE49-F238E27FC236}">
-                <a16:creationId xmlns:a16="http://schemas.microsoft.com/office/drawing/2014/main" id="{9480EE49-6533-4A72-8D33-CC2DBFA722FF}"/>
+                <a16:creationId xmlns:a16="http://schemas.microsoft.com/office/drawing/2014/main" id="{8DCBA07E-B462-4B35-96BE-0B47CAF27D8C}"/>
               </a:ext>
             </a:extLst>
           </p:cNvPr>
@@ -2328,7 +2271,7 @@
           <p:cNvPr id="7" name="text-2-6">
             <a:extLst xmlns:a="http://schemas.openxmlformats.org/drawingml/2006/main">
               <a:ext uri="{FF2B5EF4-FFF2-40B4-BE49-F238E27FC236}">
-                <a16:creationId xmlns:a16="http://schemas.microsoft.com/office/drawing/2014/main" id="{A8C809FB-3DEE-4AA0-A0CB-05791E00D75D}"/>
+                <a16:creationId xmlns:a16="http://schemas.microsoft.com/office/drawing/2014/main" id="{584533BE-8AFE-4D4A-95F0-B5732D7AA2D8}"/>
               </a:ext>
             </a:extLst>
           </p:cNvPr>
@@ -2385,7 +2328,7 @@
           <p:cNvPr id="8" name="text-2-7">
             <a:extLst xmlns:a="http://schemas.openxmlformats.org/drawingml/2006/main">
               <a:ext uri="{FF2B5EF4-FFF2-40B4-BE49-F238E27FC236}">
-                <a16:creationId xmlns:a16="http://schemas.microsoft.com/office/drawing/2014/main" id="{658693F0-A127-4E54-9E92-8FACF7DDFF42}"/>
+                <a16:creationId xmlns:a16="http://schemas.microsoft.com/office/drawing/2014/main" id="{12171F50-1BEF-4B81-B516-CDF74FD247EA}"/>
               </a:ext>
             </a:extLst>
           </p:cNvPr>
@@ -2442,7 +2385,7 @@
           <p:cNvPr id="9" name="text-2-8">
             <a:extLst xmlns:a="http://schemas.openxmlformats.org/drawingml/2006/main">
               <a:ext uri="{FF2B5EF4-FFF2-40B4-BE49-F238E27FC236}">
-                <a16:creationId xmlns:a16="http://schemas.microsoft.com/office/drawing/2014/main" id="{59EC5CCE-E6E2-4721-86A2-EAEE5D5144E5}"/>
+                <a16:creationId xmlns:a16="http://schemas.microsoft.com/office/drawing/2014/main" id="{C0ED0523-6084-4CE8-AE07-5E9C3FD43B24}"/>
               </a:ext>
             </a:extLst>
           </p:cNvPr>
@@ -2499,7 +2442,7 @@
           <p:cNvPr id="10" name="text-2-9">
             <a:extLst xmlns:a="http://schemas.openxmlformats.org/drawingml/2006/main">
               <a:ext uri="{FF2B5EF4-FFF2-40B4-BE49-F238E27FC236}">
-                <a16:creationId xmlns:a16="http://schemas.microsoft.com/office/drawing/2014/main" id="{EE7ACFD9-CEBB-4FF0-928D-2D2FC711E8B8}"/>
+                <a16:creationId xmlns:a16="http://schemas.microsoft.com/office/drawing/2014/main" id="{20C136FC-FE42-4181-A832-E270F3A25738}"/>
               </a:ext>
             </a:extLst>
           </p:cNvPr>
@@ -2554,7 +2497,7 @@
     </p:spTree>
     <p:extLst>
       <p:ext uri="{BB962C8B-B14F-4D97-AF65-F5344CB8AC3E}">
-        <p14:creationId xmlns:p14="http://schemas.microsoft.com/office/powerpoint/2010/main" val="1038678296"/>
+        <p14:creationId xmlns:p14="http://schemas.microsoft.com/office/powerpoint/2010/main" val="104831918"/>
       </p:ext>
     </p:extLst>
   </p:cSld>
@@ -2585,7 +2528,7 @@
           <p:cNvPr id="12" name="text-3-0">
             <a:extLst xmlns:a="http://schemas.openxmlformats.org/drawingml/2006/main">
               <a:ext uri="{FF2B5EF4-FFF2-40B4-BE49-F238E27FC236}">
-                <a16:creationId xmlns:a16="http://schemas.microsoft.com/office/drawing/2014/main" id="{2A6A5869-267B-4DE7-8EB6-8053C07FBE7D}"/>
+                <a16:creationId xmlns:a16="http://schemas.microsoft.com/office/drawing/2014/main" id="{715BBB54-B89E-414E-B51D-0974E5AC4358}"/>
               </a:ext>
             </a:extLst>
           </p:cNvPr>
@@ -2642,7 +2585,7 @@
           <p:cNvPr id="2" name="text-3-1">
             <a:extLst xmlns:a="http://schemas.openxmlformats.org/drawingml/2006/main">
               <a:ext uri="{FF2B5EF4-FFF2-40B4-BE49-F238E27FC236}">
-                <a16:creationId xmlns:a16="http://schemas.microsoft.com/office/drawing/2014/main" id="{99185048-D383-4BE8-B903-BD01BBCA5DE8}"/>
+                <a16:creationId xmlns:a16="http://schemas.microsoft.com/office/drawing/2014/main" id="{41550873-8C80-4943-886D-9C5626E166FD}"/>
               </a:ext>
             </a:extLst>
           </p:cNvPr>
@@ -2699,7 +2642,7 @@
           <p:cNvPr id="3" name="text-3-2">
             <a:extLst xmlns:a="http://schemas.openxmlformats.org/drawingml/2006/main">
               <a:ext uri="{FF2B5EF4-FFF2-40B4-BE49-F238E27FC236}">
-                <a16:creationId xmlns:a16="http://schemas.microsoft.com/office/drawing/2014/main" id="{44CCF051-1EEA-4AE6-8095-A213F76F03C0}"/>
+                <a16:creationId xmlns:a16="http://schemas.microsoft.com/office/drawing/2014/main" id="{79C08F22-F02F-4C59-918B-2EEE02C1D2C4}"/>
               </a:ext>
             </a:extLst>
           </p:cNvPr>
@@ -2756,7 +2699,7 @@
           <p:cNvPr id="4" name="text-3-3">
             <a:extLst xmlns:a="http://schemas.openxmlformats.org/drawingml/2006/main">
               <a:ext uri="{FF2B5EF4-FFF2-40B4-BE49-F238E27FC236}">
-                <a16:creationId xmlns:a16="http://schemas.microsoft.com/office/drawing/2014/main" id="{1B01DFD6-A006-4CA4-BD9A-D892322CFD92}"/>
+                <a16:creationId xmlns:a16="http://schemas.microsoft.com/office/drawing/2014/main" id="{FB5C8FE8-9500-4F41-AEA1-A04D284F7A6A}"/>
               </a:ext>
             </a:extLst>
           </p:cNvPr>
@@ -2813,7 +2756,7 @@
           <p:cNvPr id="5" name="text-3-4">
             <a:extLst xmlns:a="http://schemas.openxmlformats.org/drawingml/2006/main">
               <a:ext uri="{FF2B5EF4-FFF2-40B4-BE49-F238E27FC236}">
-                <a16:creationId xmlns:a16="http://schemas.microsoft.com/office/drawing/2014/main" id="{3E5E107B-E864-4053-99A8-7B7BEB26638D}"/>
+                <a16:creationId xmlns:a16="http://schemas.microsoft.com/office/drawing/2014/main" id="{FA6916E9-2F46-410A-9644-1E599B3028E7}"/>
               </a:ext>
             </a:extLst>
           </p:cNvPr>
@@ -2870,7 +2813,7 @@
           <p:cNvPr id="6" name="text-3-5">
             <a:extLst xmlns:a="http://schemas.openxmlformats.org/drawingml/2006/main">
               <a:ext uri="{FF2B5EF4-FFF2-40B4-BE49-F238E27FC236}">
-                <a16:creationId xmlns:a16="http://schemas.microsoft.com/office/drawing/2014/main" id="{9A48100F-9E7E-4633-8F91-B1E6CD606C64}"/>
+                <a16:creationId xmlns:a16="http://schemas.microsoft.com/office/drawing/2014/main" id="{6594F9DE-946E-4ACD-8006-EE31660FEA89}"/>
               </a:ext>
             </a:extLst>
           </p:cNvPr>
@@ -2927,7 +2870,7 @@
           <p:cNvPr id="7" name="text-3-6">
             <a:extLst xmlns:a="http://schemas.openxmlformats.org/drawingml/2006/main">
               <a:ext uri="{FF2B5EF4-FFF2-40B4-BE49-F238E27FC236}">
-                <a16:creationId xmlns:a16="http://schemas.microsoft.com/office/drawing/2014/main" id="{08AFA2C6-8416-4A0E-8C7A-857835B1F0A1}"/>
+                <a16:creationId xmlns:a16="http://schemas.microsoft.com/office/drawing/2014/main" id="{2A7045F2-ACD1-45C9-9181-B41B42FD4974}"/>
               </a:ext>
             </a:extLst>
           </p:cNvPr>
@@ -2984,7 +2927,7 @@
           <p:cNvPr id="8" name="text-3-7">
             <a:extLst xmlns:a="http://schemas.openxmlformats.org/drawingml/2006/main">
               <a:ext uri="{FF2B5EF4-FFF2-40B4-BE49-F238E27FC236}">
-                <a16:creationId xmlns:a16="http://schemas.microsoft.com/office/drawing/2014/main" id="{37E28050-4DB8-4136-9872-526A326CD4B0}"/>
+                <a16:creationId xmlns:a16="http://schemas.microsoft.com/office/drawing/2014/main" id="{FB30C282-8CEE-4A1E-B3BB-906917F6BF47}"/>
               </a:ext>
             </a:extLst>
           </p:cNvPr>
@@ -3041,7 +2984,7 @@
           <p:cNvPr id="9" name="text-3-8">
             <a:extLst xmlns:a="http://schemas.openxmlformats.org/drawingml/2006/main">
               <a:ext uri="{FF2B5EF4-FFF2-40B4-BE49-F238E27FC236}">
-                <a16:creationId xmlns:a16="http://schemas.microsoft.com/office/drawing/2014/main" id="{6AA8C91C-53A5-426D-80C9-C7B3260B21B5}"/>
+                <a16:creationId xmlns:a16="http://schemas.microsoft.com/office/drawing/2014/main" id="{2897A537-6D5A-46AB-8D24-56ED598F2CD9}"/>
               </a:ext>
             </a:extLst>
           </p:cNvPr>
@@ -3098,7 +3041,7 @@
           <p:cNvPr id="10" name="text-3-9">
             <a:extLst xmlns:a="http://schemas.openxmlformats.org/drawingml/2006/main">
               <a:ext uri="{FF2B5EF4-FFF2-40B4-BE49-F238E27FC236}">
-                <a16:creationId xmlns:a16="http://schemas.microsoft.com/office/drawing/2014/main" id="{361AAC86-E0D4-43A4-95EA-F28F0217A385}"/>
+                <a16:creationId xmlns:a16="http://schemas.microsoft.com/office/drawing/2014/main" id="{509B2EBC-7F3D-4A4C-854D-B5FAC393A2D4}"/>
               </a:ext>
             </a:extLst>
           </p:cNvPr>
@@ -3155,7 +3098,7 @@
           <p:cNvPr id="11" name="text-3-10">
             <a:extLst xmlns:a="http://schemas.openxmlformats.org/drawingml/2006/main">
               <a:ext uri="{FF2B5EF4-FFF2-40B4-BE49-F238E27FC236}">
-                <a16:creationId xmlns:a16="http://schemas.microsoft.com/office/drawing/2014/main" id="{59A68250-3861-44CB-B4CA-1E702DB00B2F}"/>
+                <a16:creationId xmlns:a16="http://schemas.microsoft.com/office/drawing/2014/main" id="{510BA1D2-DADF-43C6-A312-3669FB0E6D02}"/>
               </a:ext>
             </a:extLst>
           </p:cNvPr>
@@ -3210,7 +3153,7 @@
     </p:spTree>
     <p:extLst>
       <p:ext uri="{BB962C8B-B14F-4D97-AF65-F5344CB8AC3E}">
-        <p14:creationId xmlns:p14="http://schemas.microsoft.com/office/powerpoint/2010/main" val="1339280951"/>
+        <p14:creationId xmlns:p14="http://schemas.microsoft.com/office/powerpoint/2010/main" val="281634827"/>
       </p:ext>
     </p:extLst>
   </p:cSld>
@@ -3238,10 +3181,10 @@
       </p:grpSpPr>
       <p:sp>
         <p:nvSpPr>
-          <p:cNvPr id="15" name="text-4-0">
-            <a:extLst xmlns:a="http://schemas.openxmlformats.org/drawingml/2006/main">
-              <a:ext uri="{FF2B5EF4-FFF2-40B4-BE49-F238E27FC236}">
-                <a16:creationId xmlns:a16="http://schemas.microsoft.com/office/drawing/2014/main" id="{33BE6C9E-5E1A-468D-ACA1-74793243A182}"/>
+          <p:cNvPr id="14" name="text-4-0">
+            <a:extLst xmlns:a="http://schemas.openxmlformats.org/drawingml/2006/main">
+              <a:ext uri="{FF2B5EF4-FFF2-40B4-BE49-F238E27FC236}">
+                <a16:creationId xmlns:a16="http://schemas.microsoft.com/office/drawing/2014/main" id="{BAD979BA-5868-4AD0-92C2-9362B1863400}"/>
               </a:ext>
             </a:extLst>
           </p:cNvPr>
@@ -3298,7 +3241,7 @@
           <p:cNvPr id="2" name="text-4-1">
             <a:extLst xmlns:a="http://schemas.openxmlformats.org/drawingml/2006/main">
               <a:ext uri="{FF2B5EF4-FFF2-40B4-BE49-F238E27FC236}">
-                <a16:creationId xmlns:a16="http://schemas.microsoft.com/office/drawing/2014/main" id="{09C5A5E9-0C5A-4373-9D1A-97B7803F85D0}"/>
+                <a16:creationId xmlns:a16="http://schemas.microsoft.com/office/drawing/2014/main" id="{F611DB04-CB1A-47CA-8868-B0ABAE768A18}"/>
               </a:ext>
             </a:extLst>
           </p:cNvPr>
@@ -3355,7 +3298,7 @@
           <p:cNvPr id="3" name="text-4-2">
             <a:extLst xmlns:a="http://schemas.openxmlformats.org/drawingml/2006/main">
               <a:ext uri="{FF2B5EF4-FFF2-40B4-BE49-F238E27FC236}">
-                <a16:creationId xmlns:a16="http://schemas.microsoft.com/office/drawing/2014/main" id="{72F463C1-588E-4E47-A473-332D1C6B0643}"/>
+                <a16:creationId xmlns:a16="http://schemas.microsoft.com/office/drawing/2014/main" id="{B437B44C-D145-4772-84F2-AB51F10E98FC}"/>
               </a:ext>
             </a:extLst>
           </p:cNvPr>
@@ -3412,7 +3355,7 @@
           <p:cNvPr id="4" name="text-4-3">
             <a:extLst xmlns:a="http://schemas.openxmlformats.org/drawingml/2006/main">
               <a:ext uri="{FF2B5EF4-FFF2-40B4-BE49-F238E27FC236}">
-                <a16:creationId xmlns:a16="http://schemas.microsoft.com/office/drawing/2014/main" id="{CD8D382B-B0D7-496D-8838-F7815104277E}"/>
+                <a16:creationId xmlns:a16="http://schemas.microsoft.com/office/drawing/2014/main" id="{19498669-43D5-4E7F-B8C4-2131A857EA4A}"/>
               </a:ext>
             </a:extLst>
           </p:cNvPr>
@@ -3469,7 +3412,7 @@
           <p:cNvPr id="5" name="text-4-4">
             <a:extLst xmlns:a="http://schemas.openxmlformats.org/drawingml/2006/main">
               <a:ext uri="{FF2B5EF4-FFF2-40B4-BE49-F238E27FC236}">
-                <a16:creationId xmlns:a16="http://schemas.microsoft.com/office/drawing/2014/main" id="{2D0CEAB9-D9C8-4D4C-887C-8F29F66F1B0D}"/>
+                <a16:creationId xmlns:a16="http://schemas.microsoft.com/office/drawing/2014/main" id="{749AEEE0-4D23-4F30-9214-EDB76642448A}"/>
               </a:ext>
             </a:extLst>
           </p:cNvPr>
@@ -3526,7 +3469,7 @@
           <p:cNvPr id="6" name="text-4-5">
             <a:extLst xmlns:a="http://schemas.openxmlformats.org/drawingml/2006/main">
               <a:ext uri="{FF2B5EF4-FFF2-40B4-BE49-F238E27FC236}">
-                <a16:creationId xmlns:a16="http://schemas.microsoft.com/office/drawing/2014/main" id="{45D18F2D-DF93-4C7F-BB72-67FD3B78A01A}"/>
+                <a16:creationId xmlns:a16="http://schemas.microsoft.com/office/drawing/2014/main" id="{E05D2936-3061-420E-B9F5-DF716E7725D2}"/>
               </a:ext>
             </a:extLst>
           </p:cNvPr>
@@ -3583,7 +3526,7 @@
           <p:cNvPr id="7" name="text-4-6">
             <a:extLst xmlns:a="http://schemas.openxmlformats.org/drawingml/2006/main">
               <a:ext uri="{FF2B5EF4-FFF2-40B4-BE49-F238E27FC236}">
-                <a16:creationId xmlns:a16="http://schemas.microsoft.com/office/drawing/2014/main" id="{5279B3D2-C0FF-4817-8284-41989B95DEEF}"/>
+                <a16:creationId xmlns:a16="http://schemas.microsoft.com/office/drawing/2014/main" id="{30CD7D1C-6BAE-4E5A-AB53-F32405357DB2}"/>
               </a:ext>
             </a:extLst>
           </p:cNvPr>
@@ -3640,7 +3583,7 @@
           <p:cNvPr id="8" name="text-4-7">
             <a:extLst xmlns:a="http://schemas.openxmlformats.org/drawingml/2006/main">
               <a:ext uri="{FF2B5EF4-FFF2-40B4-BE49-F238E27FC236}">
-                <a16:creationId xmlns:a16="http://schemas.microsoft.com/office/drawing/2014/main" id="{95CEC96A-4249-473F-9CEF-BFD8953DABE3}"/>
+                <a16:creationId xmlns:a16="http://schemas.microsoft.com/office/drawing/2014/main" id="{FFA5B7AA-0C8B-48A9-8052-8ECCE366D884}"/>
               </a:ext>
             </a:extLst>
           </p:cNvPr>
@@ -3697,7 +3640,7 @@
           <p:cNvPr id="9" name="text-4-8">
             <a:extLst xmlns:a="http://schemas.openxmlformats.org/drawingml/2006/main">
               <a:ext uri="{FF2B5EF4-FFF2-40B4-BE49-F238E27FC236}">
-                <a16:creationId xmlns:a16="http://schemas.microsoft.com/office/drawing/2014/main" id="{94EDD6B5-67CD-435A-AEB6-921B6D405E07}"/>
+                <a16:creationId xmlns:a16="http://schemas.microsoft.com/office/drawing/2014/main" id="{CCB14DAC-ED26-4F2D-8C4F-71F0E84F3CFA}"/>
               </a:ext>
             </a:extLst>
           </p:cNvPr>
@@ -3754,7 +3697,7 @@
           <p:cNvPr id="10" name="text-4-9">
             <a:extLst xmlns:a="http://schemas.openxmlformats.org/drawingml/2006/main">
               <a:ext uri="{FF2B5EF4-FFF2-40B4-BE49-F238E27FC236}">
-                <a16:creationId xmlns:a16="http://schemas.microsoft.com/office/drawing/2014/main" id="{3B88921F-D5AB-4D22-A0CE-480E5720D264}"/>
+                <a16:creationId xmlns:a16="http://schemas.microsoft.com/office/drawing/2014/main" id="{FA7F11D9-8FE0-4E9F-8DC8-BBF26F4CD04A}"/>
               </a:ext>
             </a:extLst>
           </p:cNvPr>
@@ -3811,7 +3754,7 @@
           <p:cNvPr id="11" name="text-4-10">
             <a:extLst xmlns:a="http://schemas.openxmlformats.org/drawingml/2006/main">
               <a:ext uri="{FF2B5EF4-FFF2-40B4-BE49-F238E27FC236}">
-                <a16:creationId xmlns:a16="http://schemas.microsoft.com/office/drawing/2014/main" id="{89D463EB-B4BD-4A3A-82CA-4EC769994C16}"/>
+                <a16:creationId xmlns:a16="http://schemas.microsoft.com/office/drawing/2014/main" id="{E16531EC-330F-4D58-BB3B-23B439927412}"/>
               </a:ext>
             </a:extLst>
           </p:cNvPr>
@@ -3868,7 +3811,7 @@
           <p:cNvPr id="12" name="text-4-11">
             <a:extLst xmlns:a="http://schemas.openxmlformats.org/drawingml/2006/main">
               <a:ext uri="{FF2B5EF4-FFF2-40B4-BE49-F238E27FC236}">
-                <a16:creationId xmlns:a16="http://schemas.microsoft.com/office/drawing/2014/main" id="{933A7B29-B9A7-4A0F-A400-9869F88403A2}"/>
+                <a16:creationId xmlns:a16="http://schemas.microsoft.com/office/drawing/2014/main" id="{BDAC0F70-32F1-480E-9139-ED222913FE29}"/>
               </a:ext>
             </a:extLst>
           </p:cNvPr>
@@ -3925,64 +3868,7 @@
           <p:cNvPr id="13" name="text-4-12">
             <a:extLst xmlns:a="http://schemas.openxmlformats.org/drawingml/2006/main">
               <a:ext uri="{FF2B5EF4-FFF2-40B4-BE49-F238E27FC236}">
-                <a16:creationId xmlns:a16="http://schemas.microsoft.com/office/drawing/2014/main" id="{A9CBD651-479F-412D-A36C-B3C9069CCD4A}"/>
-              </a:ext>
-            </a:extLst>
-          </p:cNvPr>
-          <p:cNvSpPr>
-            <a:spLocks xmlns:a="http://schemas.openxmlformats.org/drawingml/2006/main" noGrp="1"/>
-          </p:cNvSpPr>
-          <p:nvPr/>
-        </p:nvSpPr>
-        <p:spPr>
-          <a:xfrm xmlns:a="http://schemas.openxmlformats.org/drawingml/2006/main">
-            <a:off x="685800" y="5524500"/>
-            <a:ext cx="10820400" cy="351663"/>
-          </a:xfrm>
-          <a:prstGeom xmlns:a="http://schemas.openxmlformats.org/drawingml/2006/main" prst="rect">
-            <a:avLst/>
-          </a:prstGeom>
-          <a:noFill xmlns:a="http://schemas.openxmlformats.org/drawingml/2006/main"/>
-          <a:ln xmlns:a="http://schemas.openxmlformats.org/drawingml/2006/main" w="0">
-            <a:noFill/>
-          </a:ln>
-        </p:spPr>
-        <p:txBody>
-          <a:bodyPr xmlns:a="http://schemas.openxmlformats.org/drawingml/2006/main" wrap="none" lIns="0" tIns="0" rIns="0" bIns="0" anchor="t">
-            <a:noAutofit/>
-          </a:bodyPr>
-          <a:lstStyle xmlns:a="http://schemas.openxmlformats.org/drawingml/2006/main"/>
-          <a:p xmlns:a="http://schemas.openxmlformats.org/drawingml/2006/main">
-            <a:pPr>
-              <a:defRPr sz="1950" b="0">
-                <a:solidFill>
-                  <a:srgbClr val="16130F"/>
-                </a:solidFill>
-                <a:latin typeface="IBM Plex Sans"/>
-                <a:ea typeface="IBM Plex Sans"/>
-                <a:cs typeface="IBM Plex Sans"/>
-              </a:defRPr>
-            </a:pPr>
-            <a:r>
-              <a:rPr sz="1950" b="0">
-                <a:solidFill>
-                  <a:srgbClr val="16130F"/>
-                </a:solidFill>
-                <a:latin typeface="IBM Plex Sans"/>
-                <a:ea typeface="IBM Plex Sans"/>
-                <a:cs typeface="IBM Plex Sans"/>
-              </a:rPr>
-              <a:t>Another website can call the program. It must follow the same rules.</a:t>
-            </a:r>
-          </a:p>
-        </p:txBody>
-      </p:sp>
-      <p:sp>
-        <p:nvSpPr>
-          <p:cNvPr id="14" name="text-4-13">
-            <a:extLst xmlns:a="http://schemas.openxmlformats.org/drawingml/2006/main">
-              <a:ext uri="{FF2B5EF4-FFF2-40B4-BE49-F238E27FC236}">
-                <a16:creationId xmlns:a16="http://schemas.microsoft.com/office/drawing/2014/main" id="{756ABBFA-C05E-4DAF-9D4D-F028CE547F27}"/>
+                <a16:creationId xmlns:a16="http://schemas.microsoft.com/office/drawing/2014/main" id="{DF645A91-E815-4A36-A7C8-2443A90529F7}"/>
               </a:ext>
             </a:extLst>
           </p:cNvPr>
@@ -4028,7 +3914,7 @@
                 <a:latin typeface="IBM Plex Sans"/>
                 <a:ea typeface="IBM Plex Sans"/>
                 <a:cs typeface="IBM Plex Sans"/>
-                <a:hlinkClick xmlns:r="http://schemas.openxmlformats.org/officeDocument/2006/relationships" r:id="Re143f6cfa23c4204"/>
+                <a:hlinkClick xmlns:r="http://schemas.openxmlformats.org/officeDocument/2006/relationships" r:id="Rd9b989c2fcf649a1"/>
               </a:rPr>
               <a:t>Token-2022 Transfer Hook documentation</a:t>
             </a:r>
@@ -4038,7 +3924,7 @@
     </p:spTree>
     <p:extLst>
       <p:ext uri="{BB962C8B-B14F-4D97-AF65-F5344CB8AC3E}">
-        <p14:creationId xmlns:p14="http://schemas.microsoft.com/office/powerpoint/2010/main" val="982391184"/>
+        <p14:creationId xmlns:p14="http://schemas.microsoft.com/office/powerpoint/2010/main" val="1515739800"/>
       </p:ext>
     </p:extLst>
   </p:cSld>
@@ -4066,10 +3952,10 @@
       </p:grpSpPr>
       <p:sp>
         <p:nvSpPr>
-          <p:cNvPr id="11" name="text-5-0">
-            <a:extLst xmlns:a="http://schemas.openxmlformats.org/drawingml/2006/main">
-              <a:ext uri="{FF2B5EF4-FFF2-40B4-BE49-F238E27FC236}">
-                <a16:creationId xmlns:a16="http://schemas.microsoft.com/office/drawing/2014/main" id="{A8E837F9-B0ED-4469-A377-CBBC4D3F6464}"/>
+          <p:cNvPr id="10" name="text-5-0">
+            <a:extLst xmlns:a="http://schemas.openxmlformats.org/drawingml/2006/main">
+              <a:ext uri="{FF2B5EF4-FFF2-40B4-BE49-F238E27FC236}">
+                <a16:creationId xmlns:a16="http://schemas.microsoft.com/office/drawing/2014/main" id="{3B1EDE05-F571-459F-A0FC-4C21160E5EF5}"/>
               </a:ext>
             </a:extLst>
           </p:cNvPr>
@@ -4126,7 +4012,7 @@
           <p:cNvPr id="2" name="text-5-1">
             <a:extLst xmlns:a="http://schemas.openxmlformats.org/drawingml/2006/main">
               <a:ext uri="{FF2B5EF4-FFF2-40B4-BE49-F238E27FC236}">
-                <a16:creationId xmlns:a16="http://schemas.microsoft.com/office/drawing/2014/main" id="{AC953149-0153-412E-9B5F-4803DEC4CB45}"/>
+                <a16:creationId xmlns:a16="http://schemas.microsoft.com/office/drawing/2014/main" id="{C6B692F4-4081-4A69-9D1C-3D3BFEF3D776}"/>
               </a:ext>
             </a:extLst>
           </p:cNvPr>
@@ -4183,7 +4069,7 @@
           <p:cNvPr id="3" name="text-5-2">
             <a:extLst xmlns:a="http://schemas.openxmlformats.org/drawingml/2006/main">
               <a:ext uri="{FF2B5EF4-FFF2-40B4-BE49-F238E27FC236}">
-                <a16:creationId xmlns:a16="http://schemas.microsoft.com/office/drawing/2014/main" id="{4C0ADDAC-0F74-441B-9B0D-0E7CBFD4E64E}"/>
+                <a16:creationId xmlns:a16="http://schemas.microsoft.com/office/drawing/2014/main" id="{84228A9D-A4CD-43A6-8519-33433DF50DB2}"/>
               </a:ext>
             </a:extLst>
           </p:cNvPr>
@@ -4240,7 +4126,7 @@
           <p:cNvPr id="4" name="text-5-3">
             <a:extLst xmlns:a="http://schemas.openxmlformats.org/drawingml/2006/main">
               <a:ext uri="{FF2B5EF4-FFF2-40B4-BE49-F238E27FC236}">
-                <a16:creationId xmlns:a16="http://schemas.microsoft.com/office/drawing/2014/main" id="{25EB012C-BD17-488F-A2C1-371EAF0AD77A}"/>
+                <a16:creationId xmlns:a16="http://schemas.microsoft.com/office/drawing/2014/main" id="{63AE2D54-0B86-4C25-81AF-5DDA843B400E}"/>
               </a:ext>
             </a:extLst>
           </p:cNvPr>
@@ -4297,7 +4183,7 @@
           <p:cNvPr id="5" name="text-5-4">
             <a:extLst xmlns:a="http://schemas.openxmlformats.org/drawingml/2006/main">
               <a:ext uri="{FF2B5EF4-FFF2-40B4-BE49-F238E27FC236}">
-                <a16:creationId xmlns:a16="http://schemas.microsoft.com/office/drawing/2014/main" id="{D1A439A1-5698-424B-84E0-8A89F8E8DA72}"/>
+                <a16:creationId xmlns:a16="http://schemas.microsoft.com/office/drawing/2014/main" id="{C95A242F-9BF9-4721-B29F-7BAFEA5652EA}"/>
               </a:ext>
             </a:extLst>
           </p:cNvPr>
@@ -4354,7 +4240,7 @@
           <p:cNvPr id="6" name="text-5-5">
             <a:extLst xmlns:a="http://schemas.openxmlformats.org/drawingml/2006/main">
               <a:ext uri="{FF2B5EF4-FFF2-40B4-BE49-F238E27FC236}">
-                <a16:creationId xmlns:a16="http://schemas.microsoft.com/office/drawing/2014/main" id="{3C281ABB-8BFD-4A60-84B6-3115E381E635}"/>
+                <a16:creationId xmlns:a16="http://schemas.microsoft.com/office/drawing/2014/main" id="{098FC10A-977C-4F3E-8B44-C11FB14C2A38}"/>
               </a:ext>
             </a:extLst>
           </p:cNvPr>
@@ -4408,7 +4294,7 @@
       </p:sp>
       <p:graphicFrame>
         <p:nvGraphicFramePr>
-          <p:cNvPr id="17" name=""/>
+          <p:cNvPr id="16" name=""/>
           <p:cNvGraphicFramePr/>
           <p:nvPr/>
         </p:nvGraphicFramePr>
@@ -4583,7 +4469,7 @@
           <p:cNvPr id="8" name="text-5-7">
             <a:extLst xmlns:a="http://schemas.openxmlformats.org/drawingml/2006/main">
               <a:ext uri="{FF2B5EF4-FFF2-40B4-BE49-F238E27FC236}">
-                <a16:creationId xmlns:a16="http://schemas.microsoft.com/office/drawing/2014/main" id="{E42E40D4-5A87-4D49-BEA3-7C4ADAAC0828}"/>
+                <a16:creationId xmlns:a16="http://schemas.microsoft.com/office/drawing/2014/main" id="{F8C54E11-93B6-4C64-98FB-87AFC208D1A1}"/>
               </a:ext>
             </a:extLst>
           </p:cNvPr>
@@ -4640,7 +4526,7 @@
           <p:cNvPr id="9" name="text-5-8">
             <a:extLst xmlns:a="http://schemas.openxmlformats.org/drawingml/2006/main">
               <a:ext uri="{FF2B5EF4-FFF2-40B4-BE49-F238E27FC236}">
-                <a16:creationId xmlns:a16="http://schemas.microsoft.com/office/drawing/2014/main" id="{9DEE001F-DDF0-4270-A32B-90F10EF507A3}"/>
+                <a16:creationId xmlns:a16="http://schemas.microsoft.com/office/drawing/2014/main" id="{291928EE-A7FB-4C07-B6B6-80AAB5951C17}"/>
               </a:ext>
             </a:extLst>
           </p:cNvPr>
@@ -4688,63 +4574,6 @@
                 <a:cs typeface="IBM Plex Sans"/>
               </a:rPr>
               <a:t>If any part fails, payment and ticket delivery roll back.</a:t>
-            </a:r>
-          </a:p>
-        </p:txBody>
-      </p:sp>
-      <p:sp>
-        <p:nvSpPr>
-          <p:cNvPr id="10" name="text-5-9">
-            <a:extLst xmlns:a="http://schemas.openxmlformats.org/drawingml/2006/main">
-              <a:ext uri="{FF2B5EF4-FFF2-40B4-BE49-F238E27FC236}">
-                <a16:creationId xmlns:a16="http://schemas.microsoft.com/office/drawing/2014/main" id="{98F4DD43-9507-46DD-8C78-6B3D679DB718}"/>
-              </a:ext>
-            </a:extLst>
-          </p:cNvPr>
-          <p:cNvSpPr>
-            <a:spLocks xmlns:a="http://schemas.openxmlformats.org/drawingml/2006/main" noGrp="1"/>
-          </p:cNvSpPr>
-          <p:nvPr/>
-        </p:nvSpPr>
-        <p:spPr>
-          <a:xfrm xmlns:a="http://schemas.openxmlformats.org/drawingml/2006/main">
-            <a:off x="685800" y="6134100"/>
-            <a:ext cx="10191750" cy="284036"/>
-          </a:xfrm>
-          <a:prstGeom xmlns:a="http://schemas.openxmlformats.org/drawingml/2006/main" prst="rect">
-            <a:avLst/>
-          </a:prstGeom>
-          <a:noFill xmlns:a="http://schemas.openxmlformats.org/drawingml/2006/main"/>
-          <a:ln xmlns:a="http://schemas.openxmlformats.org/drawingml/2006/main" w="0">
-            <a:noFill/>
-          </a:ln>
-        </p:spPr>
-        <p:txBody>
-          <a:bodyPr xmlns:a="http://schemas.openxmlformats.org/drawingml/2006/main" wrap="none" lIns="0" tIns="0" rIns="0" bIns="0" anchor="t">
-            <a:noAutofit/>
-          </a:bodyPr>
-          <a:lstStyle xmlns:a="http://schemas.openxmlformats.org/drawingml/2006/main"/>
-          <a:p xmlns:a="http://schemas.openxmlformats.org/drawingml/2006/main">
-            <a:pPr>
-              <a:defRPr sz="1575" b="0">
-                <a:solidFill>
-                  <a:srgbClr val="5B554C"/>
-                </a:solidFill>
-                <a:latin typeface="IBM Plex Sans"/>
-                <a:ea typeface="IBM Plex Sans"/>
-                <a:cs typeface="IBM Plex Sans"/>
-              </a:defRPr>
-            </a:pPr>
-            <a:r>
-              <a:rPr sz="1575" b="0">
-                <a:solidFill>
-                  <a:srgbClr val="5B554C"/>
-                </a:solidFill>
-                <a:latin typeface="IBM Plex Sans"/>
-                <a:ea typeface="IBM Plex Sans"/>
-                <a:cs typeface="IBM Plex Sans"/>
-              </a:rPr>
-              <a:t>Example uses test credits. Royalty rounds down to the nearest cent.</a:t>
             </a:r>
           </a:p>
         </p:txBody>
@@ -4752,7 +4581,7 @@
     </p:spTree>
     <p:extLst>
       <p:ext uri="{BB962C8B-B14F-4D97-AF65-F5344CB8AC3E}">
-        <p14:creationId xmlns:p14="http://schemas.microsoft.com/office/powerpoint/2010/main" val="848394895"/>
+        <p14:creationId xmlns:p14="http://schemas.microsoft.com/office/powerpoint/2010/main" val="1210736644"/>
       </p:ext>
     </p:extLst>
   </p:cSld>
@@ -4783,7 +4612,7 @@
           <p:cNvPr id="13" name="text-6-0">
             <a:extLst xmlns:a="http://schemas.openxmlformats.org/drawingml/2006/main">
               <a:ext uri="{FF2B5EF4-FFF2-40B4-BE49-F238E27FC236}">
-                <a16:creationId xmlns:a16="http://schemas.microsoft.com/office/drawing/2014/main" id="{EE4A5C9F-4B6B-42F7-8F1E-122219CFF67A}"/>
+                <a16:creationId xmlns:a16="http://schemas.microsoft.com/office/drawing/2014/main" id="{FAD109FA-A6B9-41CD-B912-57792389CF38}"/>
               </a:ext>
             </a:extLst>
           </p:cNvPr>
@@ -4840,7 +4669,7 @@
           <p:cNvPr id="2" name="text-6-1">
             <a:extLst xmlns:a="http://schemas.openxmlformats.org/drawingml/2006/main">
               <a:ext uri="{FF2B5EF4-FFF2-40B4-BE49-F238E27FC236}">
-                <a16:creationId xmlns:a16="http://schemas.microsoft.com/office/drawing/2014/main" id="{9B0561C3-828A-4506-AD9B-113FF2F04AD8}"/>
+                <a16:creationId xmlns:a16="http://schemas.microsoft.com/office/drawing/2014/main" id="{FF9FDE41-F15D-46B6-B327-B70F4FEB5B97}"/>
               </a:ext>
             </a:extLst>
           </p:cNvPr>
@@ -4887,7 +4716,7 @@
                 <a:ea typeface="IBM Plex Sans"/>
                 <a:cs typeface="IBM Plex Sans"/>
               </a:rPr>
-              <a:t>The working prototype</a:t>
+              <a:t>Transaction evidence</a:t>
             </a:r>
           </a:p>
         </p:txBody>
@@ -4897,7 +4726,7 @@
           <p:cNvPr id="3" name="text-6-2">
             <a:extLst xmlns:a="http://schemas.openxmlformats.org/drawingml/2006/main">
               <a:ext uri="{FF2B5EF4-FFF2-40B4-BE49-F238E27FC236}">
-                <a16:creationId xmlns:a16="http://schemas.microsoft.com/office/drawing/2014/main" id="{A4225FF0-9D44-4EBC-926B-6BE0517AC895}"/>
+                <a16:creationId xmlns:a16="http://schemas.microsoft.com/office/drawing/2014/main" id="{CD471873-D1C2-4AEB-BB08-7115CD722F0C}"/>
               </a:ext>
             </a:extLst>
           </p:cNvPr>
@@ -4958,7 +4787,7 @@
           <p:nvPr/>
         </p:nvPicPr>
         <p:blipFill>
-          <a:blip xmlns:r="http://schemas.openxmlformats.org/officeDocument/2006/relationships" xmlns:a="http://schemas.openxmlformats.org/drawingml/2006/main" r:embed="Re767612c1df1458d"/>
+          <a:blip xmlns:r="http://schemas.openxmlformats.org/officeDocument/2006/relationships" xmlns:a="http://schemas.openxmlformats.org/drawingml/2006/main" r:embed="R567568744da34289"/>
           <a:stretch xmlns:a="http://schemas.openxmlformats.org/drawingml/2006/main"/>
         </p:blipFill>
         <p:spPr>
@@ -4976,7 +4805,7 @@
           <p:cNvPr id="5" name="text-6-4">
             <a:extLst xmlns:a="http://schemas.openxmlformats.org/drawingml/2006/main">
               <a:ext uri="{FF2B5EF4-FFF2-40B4-BE49-F238E27FC236}">
-                <a16:creationId xmlns:a16="http://schemas.microsoft.com/office/drawing/2014/main" id="{0FF121A7-F314-431C-B2E4-560CA20B2451}"/>
+                <a16:creationId xmlns:a16="http://schemas.microsoft.com/office/drawing/2014/main" id="{148808BC-56FB-4159-870C-F540FF1806F6}"/>
               </a:ext>
             </a:extLst>
           </p:cNvPr>
@@ -5033,7 +4862,7 @@
           <p:cNvPr id="6" name="text-6-5">
             <a:extLst xmlns:a="http://schemas.openxmlformats.org/drawingml/2006/main">
               <a:ext uri="{FF2B5EF4-FFF2-40B4-BE49-F238E27FC236}">
-                <a16:creationId xmlns:a16="http://schemas.microsoft.com/office/drawing/2014/main" id="{8B38EFC8-2537-47E3-8D56-784C72EB8749}"/>
+                <a16:creationId xmlns:a16="http://schemas.microsoft.com/office/drawing/2014/main" id="{39F25740-8907-46A2-9339-4A394D4550C9}"/>
               </a:ext>
             </a:extLst>
           </p:cNvPr>
@@ -5090,7 +4919,7 @@
           <p:cNvPr id="7" name="text-6-6">
             <a:extLst xmlns:a="http://schemas.openxmlformats.org/drawingml/2006/main">
               <a:ext uri="{FF2B5EF4-FFF2-40B4-BE49-F238E27FC236}">
-                <a16:creationId xmlns:a16="http://schemas.microsoft.com/office/drawing/2014/main" id="{263DABC9-5D2E-434D-9AB7-6FEF3BBCDF39}"/>
+                <a16:creationId xmlns:a16="http://schemas.microsoft.com/office/drawing/2014/main" id="{C7A4772E-F685-4F2D-AD9D-63BD371C0B66}"/>
               </a:ext>
             </a:extLst>
           </p:cNvPr>
@@ -5136,7 +4965,7 @@
                 <a:latin typeface="IBM Plex Sans"/>
                 <a:ea typeface="IBM Plex Sans"/>
                 <a:cs typeface="IBM Plex Sans"/>
-                <a:hlinkClick xmlns:r="http://schemas.openxmlformats.org/officeDocument/2006/relationships" r:id="R967778b3b16c4011"/>
+                <a:hlinkClick xmlns:r="http://schemas.openxmlformats.org/officeDocument/2006/relationships" r:id="Rd5f996899be24605"/>
               </a:rPr>
               <a:t>Failed transaction</a:t>
             </a:r>
@@ -5148,7 +4977,7 @@
           <p:cNvPr id="8" name="text-6-7">
             <a:extLst xmlns:a="http://schemas.openxmlformats.org/drawingml/2006/main">
               <a:ext uri="{FF2B5EF4-FFF2-40B4-BE49-F238E27FC236}">
-                <a16:creationId xmlns:a16="http://schemas.microsoft.com/office/drawing/2014/main" id="{23084CD2-FA76-4920-878D-897433566554}"/>
+                <a16:creationId xmlns:a16="http://schemas.microsoft.com/office/drawing/2014/main" id="{4349E473-89CD-401A-B352-C50C6B3381FB}"/>
               </a:ext>
             </a:extLst>
           </p:cNvPr>
@@ -5205,7 +5034,7 @@
           <p:cNvPr id="9" name="text-6-8">
             <a:extLst xmlns:a="http://schemas.openxmlformats.org/drawingml/2006/main">
               <a:ext uri="{FF2B5EF4-FFF2-40B4-BE49-F238E27FC236}">
-                <a16:creationId xmlns:a16="http://schemas.microsoft.com/office/drawing/2014/main" id="{D6466F99-D075-4633-BAE1-235AB7CC389F}"/>
+                <a16:creationId xmlns:a16="http://schemas.microsoft.com/office/drawing/2014/main" id="{6D1EF8BA-07D0-42B9-BC96-2AAA6BF54F28}"/>
               </a:ext>
             </a:extLst>
           </p:cNvPr>
@@ -5262,7 +5091,7 @@
           <p:cNvPr id="10" name="text-6-9">
             <a:extLst xmlns:a="http://schemas.openxmlformats.org/drawingml/2006/main">
               <a:ext uri="{FF2B5EF4-FFF2-40B4-BE49-F238E27FC236}">
-                <a16:creationId xmlns:a16="http://schemas.microsoft.com/office/drawing/2014/main" id="{107F23C6-15E9-4E4D-84F3-50637E4EF849}"/>
+                <a16:creationId xmlns:a16="http://schemas.microsoft.com/office/drawing/2014/main" id="{067CAD08-5BAD-41CC-B587-036294F2CD2F}"/>
               </a:ext>
             </a:extLst>
           </p:cNvPr>
@@ -5308,7 +5137,7 @@
                 <a:latin typeface="IBM Plex Sans"/>
                 <a:ea typeface="IBM Plex Sans"/>
                 <a:cs typeface="IBM Plex Sans"/>
-                <a:hlinkClick xmlns:r="http://schemas.openxmlformats.org/officeDocument/2006/relationships" r:id="R1d7dec9f5ed542e1"/>
+                <a:hlinkClick xmlns:r="http://schemas.openxmlformats.org/officeDocument/2006/relationships" r:id="Rdf2a0b61976440b6"/>
               </a:rPr>
               <a:t>Failed transaction</a:t>
             </a:r>
@@ -5320,7 +5149,7 @@
           <p:cNvPr id="11" name="text-6-10">
             <a:extLst xmlns:a="http://schemas.openxmlformats.org/drawingml/2006/main">
               <a:ext uri="{FF2B5EF4-FFF2-40B4-BE49-F238E27FC236}">
-                <a16:creationId xmlns:a16="http://schemas.microsoft.com/office/drawing/2014/main" id="{7B372739-7265-494A-9971-8348C19932EF}"/>
+                <a16:creationId xmlns:a16="http://schemas.microsoft.com/office/drawing/2014/main" id="{889B61BA-147A-4145-BE5D-A7C3DE2AE7E0}"/>
               </a:ext>
             </a:extLst>
           </p:cNvPr>
@@ -5377,7 +5206,7 @@
           <p:cNvPr id="12" name="text-6-11">
             <a:extLst xmlns:a="http://schemas.openxmlformats.org/drawingml/2006/main">
               <a:ext uri="{FF2B5EF4-FFF2-40B4-BE49-F238E27FC236}">
-                <a16:creationId xmlns:a16="http://schemas.microsoft.com/office/drawing/2014/main" id="{10A63434-D7CD-43A9-8473-C03801E3E0BC}"/>
+                <a16:creationId xmlns:a16="http://schemas.microsoft.com/office/drawing/2014/main" id="{D4EF566B-7C16-46E2-BE01-DECF06678581}"/>
               </a:ext>
             </a:extLst>
           </p:cNvPr>
@@ -5423,7 +5252,7 @@
                 <a:latin typeface="IBM Plex Sans"/>
                 <a:ea typeface="IBM Plex Sans"/>
                 <a:cs typeface="IBM Plex Sans"/>
-                <a:hlinkClick xmlns:r="http://schemas.openxmlformats.org/officeDocument/2006/relationships" r:id="R09dcacc3648141b4"/>
+                <a:hlinkClick xmlns:r="http://schemas.openxmlformats.org/officeDocument/2006/relationships" r:id="R34135d015f0c47db"/>
               </a:rPr>
               <a:t>Confirmed ticket and payment</a:t>
             </a:r>
@@ -5433,7 +5262,7 @@
     </p:spTree>
     <p:extLst>
       <p:ext uri="{BB962C8B-B14F-4D97-AF65-F5344CB8AC3E}">
-        <p14:creationId xmlns:p14="http://schemas.microsoft.com/office/powerpoint/2010/main" val="238284556"/>
+        <p14:creationId xmlns:p14="http://schemas.microsoft.com/office/powerpoint/2010/main" val="1807992818"/>
       </p:ext>
     </p:extLst>
   </p:cSld>
@@ -5464,7 +5293,7 @@
           <p:cNvPr id="18" name="text-7-0">
             <a:extLst xmlns:a="http://schemas.openxmlformats.org/drawingml/2006/main">
               <a:ext uri="{FF2B5EF4-FFF2-40B4-BE49-F238E27FC236}">
-                <a16:creationId xmlns:a16="http://schemas.microsoft.com/office/drawing/2014/main" id="{A4F2224E-978C-408F-8BDF-FC4CF167609D}"/>
+                <a16:creationId xmlns:a16="http://schemas.microsoft.com/office/drawing/2014/main" id="{77FA74A1-CA2A-4334-93B0-44BEBA06F99E}"/>
               </a:ext>
             </a:extLst>
           </p:cNvPr>
@@ -5521,7 +5350,7 @@
           <p:cNvPr id="2" name="text-7-1">
             <a:extLst xmlns:a="http://schemas.openxmlformats.org/drawingml/2006/main">
               <a:ext uri="{FF2B5EF4-FFF2-40B4-BE49-F238E27FC236}">
-                <a16:creationId xmlns:a16="http://schemas.microsoft.com/office/drawing/2014/main" id="{63540651-D1AA-48E1-A633-4FC1AF77B28F}"/>
+                <a16:creationId xmlns:a16="http://schemas.microsoft.com/office/drawing/2014/main" id="{7A854A44-71F6-4FE0-839C-1FA0803F024A}"/>
               </a:ext>
             </a:extLst>
           </p:cNvPr>
@@ -5578,7 +5407,7 @@
           <p:cNvPr id="3" name="text-7-2">
             <a:extLst xmlns:a="http://schemas.openxmlformats.org/drawingml/2006/main">
               <a:ext uri="{FF2B5EF4-FFF2-40B4-BE49-F238E27FC236}">
-                <a16:creationId xmlns:a16="http://schemas.microsoft.com/office/drawing/2014/main" id="{FB230CA4-7389-4B80-9F2C-1C93C8BF5CD1}"/>
+                <a16:creationId xmlns:a16="http://schemas.microsoft.com/office/drawing/2014/main" id="{5EDF5F1E-88FC-41F6-A6AA-7F39245543F8}"/>
               </a:ext>
             </a:extLst>
           </p:cNvPr>
@@ -5635,7 +5464,7 @@
           <p:cNvPr id="4" name="text-7-3">
             <a:extLst xmlns:a="http://schemas.openxmlformats.org/drawingml/2006/main">
               <a:ext uri="{FF2B5EF4-FFF2-40B4-BE49-F238E27FC236}">
-                <a16:creationId xmlns:a16="http://schemas.microsoft.com/office/drawing/2014/main" id="{B597E88B-6A28-484A-AF0B-CD242759172F}"/>
+                <a16:creationId xmlns:a16="http://schemas.microsoft.com/office/drawing/2014/main" id="{586787ED-08D5-4DA5-AD6D-0F3C285AB0FF}"/>
               </a:ext>
             </a:extLst>
           </p:cNvPr>
@@ -5692,7 +5521,7 @@
           <p:cNvPr id="5" name="text-7-4">
             <a:extLst xmlns:a="http://schemas.openxmlformats.org/drawingml/2006/main">
               <a:ext uri="{FF2B5EF4-FFF2-40B4-BE49-F238E27FC236}">
-                <a16:creationId xmlns:a16="http://schemas.microsoft.com/office/drawing/2014/main" id="{E278876E-5851-405A-AE79-D50EB39741D4}"/>
+                <a16:creationId xmlns:a16="http://schemas.microsoft.com/office/drawing/2014/main" id="{95F5F669-C0C3-4BFA-904D-CE99A6668833}"/>
               </a:ext>
             </a:extLst>
           </p:cNvPr>
@@ -5749,7 +5578,7 @@
           <p:cNvPr id="6" name="text-7-5">
             <a:extLst xmlns:a="http://schemas.openxmlformats.org/drawingml/2006/main">
               <a:ext uri="{FF2B5EF4-FFF2-40B4-BE49-F238E27FC236}">
-                <a16:creationId xmlns:a16="http://schemas.microsoft.com/office/drawing/2014/main" id="{0ED775EB-40DE-48EC-9E91-DFBEEF2F8C1C}"/>
+                <a16:creationId xmlns:a16="http://schemas.microsoft.com/office/drawing/2014/main" id="{243588B6-1ACB-4E02-8FC6-0B07706D7E54}"/>
               </a:ext>
             </a:extLst>
           </p:cNvPr>
@@ -5806,7 +5635,7 @@
           <p:cNvPr id="7" name="text-7-6">
             <a:extLst xmlns:a="http://schemas.openxmlformats.org/drawingml/2006/main">
               <a:ext uri="{FF2B5EF4-FFF2-40B4-BE49-F238E27FC236}">
-                <a16:creationId xmlns:a16="http://schemas.microsoft.com/office/drawing/2014/main" id="{B4231347-4B1A-48ED-A569-9220E792668B}"/>
+                <a16:creationId xmlns:a16="http://schemas.microsoft.com/office/drawing/2014/main" id="{B5F330B7-4CA5-4E56-897A-699B13924161}"/>
               </a:ext>
             </a:extLst>
           </p:cNvPr>
@@ -5863,7 +5692,7 @@
           <p:cNvPr id="8" name="text-7-7">
             <a:extLst xmlns:a="http://schemas.openxmlformats.org/drawingml/2006/main">
               <a:ext uri="{FF2B5EF4-FFF2-40B4-BE49-F238E27FC236}">
-                <a16:creationId xmlns:a16="http://schemas.microsoft.com/office/drawing/2014/main" id="{CE862DE8-FA8B-464E-8196-FCE230D06B3E}"/>
+                <a16:creationId xmlns:a16="http://schemas.microsoft.com/office/drawing/2014/main" id="{C4945855-96A9-4190-B3D6-D657624662DB}"/>
               </a:ext>
             </a:extLst>
           </p:cNvPr>
@@ -5920,7 +5749,7 @@
           <p:cNvPr id="9" name="text-7-8">
             <a:extLst xmlns:a="http://schemas.openxmlformats.org/drawingml/2006/main">
               <a:ext uri="{FF2B5EF4-FFF2-40B4-BE49-F238E27FC236}">
-                <a16:creationId xmlns:a16="http://schemas.microsoft.com/office/drawing/2014/main" id="{B5DEE96C-EDA8-47F1-A78D-396465199E6A}"/>
+                <a16:creationId xmlns:a16="http://schemas.microsoft.com/office/drawing/2014/main" id="{218AB1DA-6D8E-4D98-8E21-1884EBCA9A36}"/>
               </a:ext>
             </a:extLst>
           </p:cNvPr>
@@ -5977,7 +5806,7 @@
           <p:cNvPr id="10" name="text-7-9">
             <a:extLst xmlns:a="http://schemas.openxmlformats.org/drawingml/2006/main">
               <a:ext uri="{FF2B5EF4-FFF2-40B4-BE49-F238E27FC236}">
-                <a16:creationId xmlns:a16="http://schemas.microsoft.com/office/drawing/2014/main" id="{B89282B9-46BF-4121-A9F7-6AAF24B79438}"/>
+                <a16:creationId xmlns:a16="http://schemas.microsoft.com/office/drawing/2014/main" id="{977B316A-AE66-41C8-947C-412198EE1C40}"/>
               </a:ext>
             </a:extLst>
           </p:cNvPr>
@@ -6034,7 +5863,7 @@
           <p:cNvPr id="11" name="text-7-10">
             <a:extLst xmlns:a="http://schemas.openxmlformats.org/drawingml/2006/main">
               <a:ext uri="{FF2B5EF4-FFF2-40B4-BE49-F238E27FC236}">
-                <a16:creationId xmlns:a16="http://schemas.microsoft.com/office/drawing/2014/main" id="{4803B5D6-9277-403E-96BF-9503C36E1E43}"/>
+                <a16:creationId xmlns:a16="http://schemas.microsoft.com/office/drawing/2014/main" id="{F1650D94-2029-4B3F-868D-B48B743BDD1E}"/>
               </a:ext>
             </a:extLst>
           </p:cNvPr>
@@ -6091,7 +5920,7 @@
           <p:cNvPr id="12" name="text-7-11">
             <a:extLst xmlns:a="http://schemas.openxmlformats.org/drawingml/2006/main">
               <a:ext uri="{FF2B5EF4-FFF2-40B4-BE49-F238E27FC236}">
-                <a16:creationId xmlns:a16="http://schemas.microsoft.com/office/drawing/2014/main" id="{3750E539-6533-42A2-83E4-A0BBB4767C38}"/>
+                <a16:creationId xmlns:a16="http://schemas.microsoft.com/office/drawing/2014/main" id="{6771C7AE-1B89-4728-8A23-516B38D0BFA8}"/>
               </a:ext>
             </a:extLst>
           </p:cNvPr>
@@ -6148,7 +5977,7 @@
           <p:cNvPr id="13" name="text-7-12">
             <a:extLst xmlns:a="http://schemas.openxmlformats.org/drawingml/2006/main">
               <a:ext uri="{FF2B5EF4-FFF2-40B4-BE49-F238E27FC236}">
-                <a16:creationId xmlns:a16="http://schemas.microsoft.com/office/drawing/2014/main" id="{D54B1942-B07C-478D-B092-EEB89F2B6625}"/>
+                <a16:creationId xmlns:a16="http://schemas.microsoft.com/office/drawing/2014/main" id="{31F52B51-CE11-4858-A76F-B39A355241F8}"/>
               </a:ext>
             </a:extLst>
           </p:cNvPr>
@@ -6194,7 +6023,7 @@
                 <a:latin typeface="IBM Plex Sans"/>
                 <a:ea typeface="IBM Plex Sans"/>
                 <a:cs typeface="IBM Plex Sans"/>
-                <a:hlinkClick xmlns:r="http://schemas.openxmlformats.org/officeDocument/2006/relationships" r:id="Ra9238e306a874747"/>
+                <a:hlinkClick xmlns:r="http://schemas.openxmlformats.org/officeDocument/2006/relationships" r:id="R66f6fa5b56b64183"/>
               </a:rPr>
               <a:t>Deployed marketplace</a:t>
             </a:r>
@@ -6206,7 +6035,7 @@
           <p:cNvPr id="14" name="text-7-13">
             <a:extLst xmlns:a="http://schemas.openxmlformats.org/drawingml/2006/main">
               <a:ext uri="{FF2B5EF4-FFF2-40B4-BE49-F238E27FC236}">
-                <a16:creationId xmlns:a16="http://schemas.microsoft.com/office/drawing/2014/main" id="{4589D953-DB55-4997-AEFA-1A1D78F9950B}"/>
+                <a16:creationId xmlns:a16="http://schemas.microsoft.com/office/drawing/2014/main" id="{8D03E496-B074-470F-89B8-2D5B3DE100F2}"/>
               </a:ext>
             </a:extLst>
           </p:cNvPr>
@@ -6252,7 +6081,7 @@
                 <a:latin typeface="IBM Plex Sans"/>
                 <a:ea typeface="IBM Plex Sans"/>
                 <a:cs typeface="IBM Plex Sans"/>
-                <a:hlinkClick xmlns:r="http://schemas.openxmlformats.org/officeDocument/2006/relationships" r:id="R4e7250b8ae514805"/>
+                <a:hlinkClick xmlns:r="http://schemas.openxmlformats.org/officeDocument/2006/relationships" r:id="R311fb7f749f74309"/>
               </a:rPr>
               <a:t>Marketplace source</a:t>
             </a:r>
@@ -6264,7 +6093,7 @@
           <p:cNvPr id="15" name="text-7-14">
             <a:extLst xmlns:a="http://schemas.openxmlformats.org/drawingml/2006/main">
               <a:ext uri="{FF2B5EF4-FFF2-40B4-BE49-F238E27FC236}">
-                <a16:creationId xmlns:a16="http://schemas.microsoft.com/office/drawing/2014/main" id="{832060BC-1EE2-4A0E-AFBE-1669D711AA5C}"/>
+                <a16:creationId xmlns:a16="http://schemas.microsoft.com/office/drawing/2014/main" id="{88C8A30F-CAD6-4458-A7D0-75A0ABCACE00}"/>
               </a:ext>
             </a:extLst>
           </p:cNvPr>
@@ -6310,7 +6139,7 @@
                 <a:latin typeface="IBM Plex Sans"/>
                 <a:ea typeface="IBM Plex Sans"/>
                 <a:cs typeface="IBM Plex Sans"/>
-                <a:hlinkClick xmlns:r="http://schemas.openxmlformats.org/officeDocument/2006/relationships" r:id="Rbd43a8d5ed0941ae"/>
+                <a:hlinkClick xmlns:r="http://schemas.openxmlformats.org/officeDocument/2006/relationships" r:id="Rc5050a6f3a9744e0"/>
               </a:rPr>
               <a:t>Deployed transfer hook</a:t>
             </a:r>
@@ -6322,7 +6151,7 @@
           <p:cNvPr id="16" name="text-7-15">
             <a:extLst xmlns:a="http://schemas.openxmlformats.org/drawingml/2006/main">
               <a:ext uri="{FF2B5EF4-FFF2-40B4-BE49-F238E27FC236}">
-                <a16:creationId xmlns:a16="http://schemas.microsoft.com/office/drawing/2014/main" id="{746FD774-2F5C-40BF-9967-F8D21D226C3A}"/>
+                <a16:creationId xmlns:a16="http://schemas.microsoft.com/office/drawing/2014/main" id="{800AE057-C16D-48C8-A3CC-942ECAEB3881}"/>
               </a:ext>
             </a:extLst>
           </p:cNvPr>
@@ -6368,7 +6197,7 @@
                 <a:latin typeface="IBM Plex Sans"/>
                 <a:ea typeface="IBM Plex Sans"/>
                 <a:cs typeface="IBM Plex Sans"/>
-                <a:hlinkClick xmlns:r="http://schemas.openxmlformats.org/officeDocument/2006/relationships" r:id="R2fd62e6911194590"/>
+                <a:hlinkClick xmlns:r="http://schemas.openxmlformats.org/officeDocument/2006/relationships" r:id="R2d0528de4e7242bb"/>
               </a:rPr>
               <a:t>Transfer hook source</a:t>
             </a:r>
@@ -6380,7 +6209,7 @@
           <p:cNvPr id="17" name="text-7-16">
             <a:extLst xmlns:a="http://schemas.openxmlformats.org/drawingml/2006/main">
               <a:ext uri="{FF2B5EF4-FFF2-40B4-BE49-F238E27FC236}">
-                <a16:creationId xmlns:a16="http://schemas.microsoft.com/office/drawing/2014/main" id="{FBAA008F-F069-41C4-9DBD-AEB6B54B641A}"/>
+                <a16:creationId xmlns:a16="http://schemas.microsoft.com/office/drawing/2014/main" id="{BE666771-4D48-4FF8-96B4-83B9F640B5FC}"/>
               </a:ext>
             </a:extLst>
           </p:cNvPr>
@@ -6426,7 +6255,7 @@
                 <a:latin typeface="IBM Plex Sans"/>
                 <a:ea typeface="IBM Plex Sans"/>
                 <a:cs typeface="IBM Plex Sans"/>
-                <a:hlinkClick xmlns:r="http://schemas.openxmlformats.org/officeDocument/2006/relationships" r:id="R9b1caafc9c1748d1"/>
+                <a:hlinkClick xmlns:r="http://schemas.openxmlformats.org/officeDocument/2006/relationships" r:id="R31a66f10df8249ba"/>
               </a:rPr>
               <a:t>Token accounts have immutable owners to block an authority change.</a:t>
             </a:r>
@@ -6436,7 +6265,7 @@
     </p:spTree>
     <p:extLst>
       <p:ext uri="{BB962C8B-B14F-4D97-AF65-F5344CB8AC3E}">
-        <p14:creationId xmlns:p14="http://schemas.microsoft.com/office/powerpoint/2010/main" val="1235459561"/>
+        <p14:creationId xmlns:p14="http://schemas.microsoft.com/office/powerpoint/2010/main" val="298437476"/>
       </p:ext>
     </p:extLst>
   </p:cSld>
@@ -6464,10 +6293,10 @@
       </p:grpSpPr>
       <p:sp>
         <p:nvSpPr>
-          <p:cNvPr id="12" name="text-8-0">
-            <a:extLst xmlns:a="http://schemas.openxmlformats.org/drawingml/2006/main">
-              <a:ext uri="{FF2B5EF4-FFF2-40B4-BE49-F238E27FC236}">
-                <a16:creationId xmlns:a16="http://schemas.microsoft.com/office/drawing/2014/main" id="{B6D8111A-ED6A-4C13-8E68-0BF208339AC1}"/>
+          <p:cNvPr id="4" name="text-8-0">
+            <a:extLst xmlns:a="http://schemas.openxmlformats.org/drawingml/2006/main">
+              <a:ext uri="{FF2B5EF4-FFF2-40B4-BE49-F238E27FC236}">
+                <a16:creationId xmlns:a16="http://schemas.microsoft.com/office/drawing/2014/main" id="{C226B68D-0C8A-49FA-A08B-4EFB4E2E5FFF}"/>
               </a:ext>
             </a:extLst>
           </p:cNvPr>
@@ -6524,93 +6353,36 @@
           <p:cNvPr id="2" name="text-8-1">
             <a:extLst xmlns:a="http://schemas.openxmlformats.org/drawingml/2006/main">
               <a:ext uri="{FF2B5EF4-FFF2-40B4-BE49-F238E27FC236}">
-                <a16:creationId xmlns:a16="http://schemas.microsoft.com/office/drawing/2014/main" id="{53A5D3FC-C322-4AA4-95C6-3DC91C224F90}"/>
-              </a:ext>
-            </a:extLst>
-          </p:cNvPr>
-          <p:cNvSpPr>
-            <a:spLocks xmlns:a="http://schemas.openxmlformats.org/drawingml/2006/main" noGrp="1"/>
-          </p:cNvSpPr>
-          <p:nvPr/>
-        </p:nvSpPr>
-        <p:spPr>
-          <a:xfrm xmlns:a="http://schemas.openxmlformats.org/drawingml/2006/main">
-            <a:off x="685800" y="552450"/>
-            <a:ext cx="9525000" cy="297561"/>
-          </a:xfrm>
-          <a:prstGeom xmlns:a="http://schemas.openxmlformats.org/drawingml/2006/main" prst="rect">
-            <a:avLst/>
-          </a:prstGeom>
-          <a:noFill xmlns:a="http://schemas.openxmlformats.org/drawingml/2006/main"/>
-          <a:ln xmlns:a="http://schemas.openxmlformats.org/drawingml/2006/main" w="0">
-            <a:noFill/>
-          </a:ln>
-        </p:spPr>
-        <p:txBody>
-          <a:bodyPr xmlns:a="http://schemas.openxmlformats.org/drawingml/2006/main" wrap="none" lIns="0" tIns="0" rIns="0" bIns="0" anchor="t">
-            <a:noAutofit/>
-          </a:bodyPr>
-          <a:lstStyle xmlns:a="http://schemas.openxmlformats.org/drawingml/2006/main"/>
-          <a:p xmlns:a="http://schemas.openxmlformats.org/drawingml/2006/main">
-            <a:pPr>
-              <a:defRPr sz="1650" b="0">
-                <a:solidFill>
-                  <a:srgbClr val="16130F"/>
-                </a:solidFill>
-                <a:latin typeface="IBM Plex Sans"/>
-                <a:ea typeface="IBM Plex Sans"/>
-                <a:cs typeface="IBM Plex Sans"/>
-              </a:defRPr>
-            </a:pPr>
-            <a:r>
-              <a:rPr sz="1650" b="0">
-                <a:solidFill>
-                  <a:srgbClr val="16130F"/>
-                </a:solidFill>
-                <a:latin typeface="IBM Plex Sans"/>
-                <a:ea typeface="IBM Plex Sans"/>
-                <a:cs typeface="IBM Plex Sans"/>
-              </a:rPr>
-              <a:t>The live prototype</a:t>
-            </a:r>
-          </a:p>
-        </p:txBody>
-      </p:sp>
-      <p:sp>
-        <p:nvSpPr>
-          <p:cNvPr id="3" name="text-8-2">
-            <a:extLst xmlns:a="http://schemas.openxmlformats.org/drawingml/2006/main">
-              <a:ext uri="{FF2B5EF4-FFF2-40B4-BE49-F238E27FC236}">
-                <a16:creationId xmlns:a16="http://schemas.microsoft.com/office/drawing/2014/main" id="{D0F51A7E-8474-48A0-BC3E-FBE900639CD7}"/>
-              </a:ext>
-            </a:extLst>
-          </p:cNvPr>
-          <p:cNvSpPr>
-            <a:spLocks xmlns:a="http://schemas.openxmlformats.org/drawingml/2006/main" noGrp="1"/>
-          </p:cNvSpPr>
-          <p:nvPr/>
-        </p:nvSpPr>
-        <p:spPr>
-          <a:xfrm xmlns:a="http://schemas.openxmlformats.org/drawingml/2006/main">
-            <a:off x="685800" y="1057275"/>
-            <a:ext cx="10820400" cy="892683"/>
-          </a:xfrm>
-          <a:prstGeom xmlns:a="http://schemas.openxmlformats.org/drawingml/2006/main" prst="rect">
-            <a:avLst/>
-          </a:prstGeom>
-          <a:noFill xmlns:a="http://schemas.openxmlformats.org/drawingml/2006/main"/>
-          <a:ln xmlns:a="http://schemas.openxmlformats.org/drawingml/2006/main" w="0">
-            <a:noFill/>
-          </a:ln>
-        </p:spPr>
-        <p:txBody>
-          <a:bodyPr xmlns:a="http://schemas.openxmlformats.org/drawingml/2006/main" wrap="none" lIns="0" tIns="0" rIns="0" bIns="0" anchor="t">
-            <a:noAutofit/>
-          </a:bodyPr>
-          <a:lstStyle xmlns:a="http://schemas.openxmlformats.org/drawingml/2006/main"/>
-          <a:p xmlns:a="http://schemas.openxmlformats.org/drawingml/2006/main">
-            <a:pPr>
-              <a:defRPr sz="4950" b="1">
+                <a16:creationId xmlns:a16="http://schemas.microsoft.com/office/drawing/2014/main" id="{AA6E2DCD-3179-4635-8143-6ADF614959A1}"/>
+              </a:ext>
+            </a:extLst>
+          </p:cNvPr>
+          <p:cNvSpPr>
+            <a:spLocks xmlns:a="http://schemas.openxmlformats.org/drawingml/2006/main" noGrp="1"/>
+          </p:cNvSpPr>
+          <p:nvPr/>
+        </p:nvSpPr>
+        <p:spPr>
+          <a:xfrm xmlns:a="http://schemas.openxmlformats.org/drawingml/2006/main">
+            <a:off x="685800" y="1847850"/>
+            <a:ext cx="10820400" cy="1893570"/>
+          </a:xfrm>
+          <a:prstGeom xmlns:a="http://schemas.openxmlformats.org/drawingml/2006/main" prst="rect">
+            <a:avLst/>
+          </a:prstGeom>
+          <a:noFill xmlns:a="http://schemas.openxmlformats.org/drawingml/2006/main"/>
+          <a:ln xmlns:a="http://schemas.openxmlformats.org/drawingml/2006/main" w="0">
+            <a:noFill/>
+          </a:ln>
+        </p:spPr>
+        <p:txBody>
+          <a:bodyPr xmlns:a="http://schemas.openxmlformats.org/drawingml/2006/main" wrap="none" lIns="0" tIns="0" rIns="0" bIns="0" anchor="t">
+            <a:noAutofit/>
+          </a:bodyPr>
+          <a:lstStyle xmlns:a="http://schemas.openxmlformats.org/drawingml/2006/main"/>
+          <a:p xmlns:a="http://schemas.openxmlformats.org/drawingml/2006/main">
+            <a:pPr>
+              <a:defRPr sz="10500" b="1">
                 <a:solidFill>
                   <a:srgbClr val="16130F"/>
                 </a:solidFill>
@@ -6620,7 +6392,7 @@
               </a:defRPr>
             </a:pPr>
             <a:r>
-              <a:rPr sz="4950" b="1">
+              <a:rPr sz="10500" b="1">
                 <a:solidFill>
                   <a:srgbClr val="16130F"/>
                 </a:solidFill>
@@ -6628,28 +6400,28 @@
                 <a:ea typeface="Archivo"/>
                 <a:cs typeface="Archivo"/>
               </a:rPr>
-              <a:t>A resale you can verify</a:t>
-            </a:r>
-          </a:p>
-        </p:txBody>
-      </p:sp>
-      <p:sp>
-        <p:nvSpPr>
-          <p:cNvPr id="4" name="text-8-3">
-            <a:extLst xmlns:a="http://schemas.openxmlformats.org/drawingml/2006/main">
-              <a:ext uri="{FF2B5EF4-FFF2-40B4-BE49-F238E27FC236}">
-                <a16:creationId xmlns:a16="http://schemas.microsoft.com/office/drawing/2014/main" id="{B8424D35-4987-4BB2-BF57-525E63ED8623}"/>
-              </a:ext>
-            </a:extLst>
-          </p:cNvPr>
-          <p:cNvSpPr>
-            <a:spLocks xmlns:a="http://schemas.openxmlformats.org/drawingml/2006/main" noGrp="1"/>
-          </p:cNvSpPr>
-          <p:nvPr/>
-        </p:nvSpPr>
-        <p:spPr>
-          <a:xfrm xmlns:a="http://schemas.openxmlformats.org/drawingml/2006/main">
-            <a:off x="685800" y="2362200"/>
+              <a:t>fairtix.</a:t>
+            </a:r>
+          </a:p>
+        </p:txBody>
+      </p:sp>
+      <p:sp>
+        <p:nvSpPr>
+          <p:cNvPr id="3" name="text-8-2">
+            <a:extLst xmlns:a="http://schemas.openxmlformats.org/drawingml/2006/main">
+              <a:ext uri="{FF2B5EF4-FFF2-40B4-BE49-F238E27FC236}">
+                <a16:creationId xmlns:a16="http://schemas.microsoft.com/office/drawing/2014/main" id="{821B3790-3CE3-44B2-8303-F31C51A364C0}"/>
+              </a:ext>
+            </a:extLst>
+          </p:cNvPr>
+          <p:cNvSpPr>
+            <a:spLocks xmlns:a="http://schemas.openxmlformats.org/drawingml/2006/main" noGrp="1"/>
+          </p:cNvSpPr>
+          <p:nvPr/>
+        </p:nvSpPr>
+        <p:spPr>
+          <a:xfrm xmlns:a="http://schemas.openxmlformats.org/drawingml/2006/main">
+            <a:off x="685800" y="4076700"/>
             <a:ext cx="10820400" cy="595122"/>
           </a:xfrm>
           <a:prstGeom xmlns:a="http://schemas.openxmlformats.org/drawingml/2006/main" prst="rect">
@@ -6684,408 +6456,9 @@
                 <a:latin typeface="IBM Plex Mono"/>
                 <a:ea typeface="IBM Plex Mono"/>
                 <a:cs typeface="IBM Plex Mono"/>
-                <a:hlinkClick xmlns:r="http://schemas.openxmlformats.org/officeDocument/2006/relationships" r:id="R55eb78c43ae54fe4"/>
+                <a:hlinkClick xmlns:r="http://schemas.openxmlformats.org/officeDocument/2006/relationships" r:id="R2b57c2450a9740fe"/>
               </a:rPr>
               <a:t>fairtix-whu.vercel.app/demo</a:t>
-            </a:r>
-          </a:p>
-        </p:txBody>
-      </p:sp>
-      <p:sp>
-        <p:nvSpPr>
-          <p:cNvPr id="5" name="text-8-4">
-            <a:extLst xmlns:a="http://schemas.openxmlformats.org/drawingml/2006/main">
-              <a:ext uri="{FF2B5EF4-FFF2-40B4-BE49-F238E27FC236}">
-                <a16:creationId xmlns:a16="http://schemas.microsoft.com/office/drawing/2014/main" id="{CB0AFEC1-1613-4164-989E-31151B4621AE}"/>
-              </a:ext>
-            </a:extLst>
-          </p:cNvPr>
-          <p:cNvSpPr>
-            <a:spLocks xmlns:a="http://schemas.openxmlformats.org/drawingml/2006/main" noGrp="1"/>
-          </p:cNvSpPr>
-          <p:nvPr/>
-        </p:nvSpPr>
-        <p:spPr>
-          <a:xfrm xmlns:a="http://schemas.openxmlformats.org/drawingml/2006/main">
-            <a:off x="685800" y="3314700"/>
-            <a:ext cx="10820400" cy="405765"/>
-          </a:xfrm>
-          <a:prstGeom xmlns:a="http://schemas.openxmlformats.org/drawingml/2006/main" prst="rect">
-            <a:avLst/>
-          </a:prstGeom>
-          <a:noFill xmlns:a="http://schemas.openxmlformats.org/drawingml/2006/main"/>
-          <a:ln xmlns:a="http://schemas.openxmlformats.org/drawingml/2006/main" w="0">
-            <a:noFill/>
-          </a:ln>
-        </p:spPr>
-        <p:txBody>
-          <a:bodyPr xmlns:a="http://schemas.openxmlformats.org/drawingml/2006/main" wrap="none" lIns="0" tIns="0" rIns="0" bIns="0" anchor="t">
-            <a:noAutofit/>
-          </a:bodyPr>
-          <a:lstStyle xmlns:a="http://schemas.openxmlformats.org/drawingml/2006/main"/>
-          <a:p xmlns:a="http://schemas.openxmlformats.org/drawingml/2006/main">
-            <a:pPr>
-              <a:defRPr sz="2250" b="0">
-                <a:solidFill>
-                  <a:srgbClr val="16130F"/>
-                </a:solidFill>
-                <a:latin typeface="IBM Plex Sans"/>
-                <a:ea typeface="IBM Plex Sans"/>
-                <a:cs typeface="IBM Plex Sans"/>
-              </a:defRPr>
-            </a:pPr>
-            <a:r>
-              <a:rPr sz="2250" b="0">
-                <a:solidFill>
-                  <a:srgbClr val="16130F"/>
-                </a:solidFill>
-                <a:latin typeface="IBM Plex Sans"/>
-                <a:ea typeface="IBM Plex Sans"/>
-                <a:cs typeface="IBM Plex Sans"/>
-              </a:rPr>
-              <a:t>Buy as the seller. Test the €60 request and direct transfer.</a:t>
-            </a:r>
-          </a:p>
-        </p:txBody>
-      </p:sp>
-      <p:sp>
-        <p:nvSpPr>
-          <p:cNvPr id="6" name="text-8-5">
-            <a:extLst xmlns:a="http://schemas.openxmlformats.org/drawingml/2006/main">
-              <a:ext uri="{FF2B5EF4-FFF2-40B4-BE49-F238E27FC236}">
-                <a16:creationId xmlns:a16="http://schemas.microsoft.com/office/drawing/2014/main" id="{B0224635-2DBB-43A4-9676-11F0079030B7}"/>
-              </a:ext>
-            </a:extLst>
-          </p:cNvPr>
-          <p:cNvSpPr>
-            <a:spLocks xmlns:a="http://schemas.openxmlformats.org/drawingml/2006/main" noGrp="1"/>
-          </p:cNvSpPr>
-          <p:nvPr/>
-        </p:nvSpPr>
-        <p:spPr>
-          <a:xfrm xmlns:a="http://schemas.openxmlformats.org/drawingml/2006/main">
-            <a:off x="685800" y="3686175"/>
-            <a:ext cx="10820400" cy="405765"/>
-          </a:xfrm>
-          <a:prstGeom xmlns:a="http://schemas.openxmlformats.org/drawingml/2006/main" prst="rect">
-            <a:avLst/>
-          </a:prstGeom>
-          <a:noFill xmlns:a="http://schemas.openxmlformats.org/drawingml/2006/main"/>
-          <a:ln xmlns:a="http://schemas.openxmlformats.org/drawingml/2006/main" w="0">
-            <a:noFill/>
-          </a:ln>
-        </p:spPr>
-        <p:txBody>
-          <a:bodyPr xmlns:a="http://schemas.openxmlformats.org/drawingml/2006/main" wrap="none" lIns="0" tIns="0" rIns="0" bIns="0" anchor="t">
-            <a:noAutofit/>
-          </a:bodyPr>
-          <a:lstStyle xmlns:a="http://schemas.openxmlformats.org/drawingml/2006/main"/>
-          <a:p xmlns:a="http://schemas.openxmlformats.org/drawingml/2006/main">
-            <a:pPr>
-              <a:defRPr sz="2250" b="0">
-                <a:solidFill>
-                  <a:srgbClr val="16130F"/>
-                </a:solidFill>
-                <a:latin typeface="IBM Plex Sans"/>
-                <a:ea typeface="IBM Plex Sans"/>
-                <a:cs typeface="IBM Plex Sans"/>
-              </a:defRPr>
-            </a:pPr>
-            <a:r>
-              <a:rPr sz="2250" b="0">
-                <a:solidFill>
-                  <a:srgbClr val="16130F"/>
-                </a:solidFill>
-                <a:latin typeface="IBM Plex Sans"/>
-                <a:ea typeface="IBM Plex Sans"/>
-                <a:cs typeface="IBM Plex Sans"/>
-              </a:rPr>
-              <a:t>Then complete a €27.50 resale as the buyer.</a:t>
-            </a:r>
-          </a:p>
-        </p:txBody>
-      </p:sp>
-      <p:sp>
-        <p:nvSpPr>
-          <p:cNvPr id="7" name="text-8-6">
-            <a:extLst xmlns:a="http://schemas.openxmlformats.org/drawingml/2006/main">
-              <a:ext uri="{FF2B5EF4-FFF2-40B4-BE49-F238E27FC236}">
-                <a16:creationId xmlns:a16="http://schemas.microsoft.com/office/drawing/2014/main" id="{07F3CECD-99B4-4AA9-8405-28445C1C6ABC}"/>
-              </a:ext>
-            </a:extLst>
-          </p:cNvPr>
-          <p:cNvSpPr>
-            <a:spLocks xmlns:a="http://schemas.openxmlformats.org/drawingml/2006/main" noGrp="1"/>
-          </p:cNvSpPr>
-          <p:nvPr/>
-        </p:nvSpPr>
-        <p:spPr>
-          <a:xfrm xmlns:a="http://schemas.openxmlformats.org/drawingml/2006/main">
-            <a:off x="685800" y="4810125"/>
-            <a:ext cx="10820400" cy="405765"/>
-          </a:xfrm>
-          <a:prstGeom xmlns:a="http://schemas.openxmlformats.org/drawingml/2006/main" prst="rect">
-            <a:avLst/>
-          </a:prstGeom>
-          <a:noFill xmlns:a="http://schemas.openxmlformats.org/drawingml/2006/main"/>
-          <a:ln xmlns:a="http://schemas.openxmlformats.org/drawingml/2006/main" w="0">
-            <a:noFill/>
-          </a:ln>
-        </p:spPr>
-        <p:txBody>
-          <a:bodyPr xmlns:a="http://schemas.openxmlformats.org/drawingml/2006/main" wrap="none" lIns="0" tIns="0" rIns="0" bIns="0" anchor="t">
-            <a:noAutofit/>
-          </a:bodyPr>
-          <a:lstStyle xmlns:a="http://schemas.openxmlformats.org/drawingml/2006/main"/>
-          <a:p xmlns:a="http://schemas.openxmlformats.org/drawingml/2006/main">
-            <a:pPr>
-              <a:defRPr sz="2250" b="1">
-                <a:solidFill>
-                  <a:srgbClr val="16130F"/>
-                </a:solidFill>
-                <a:latin typeface="Archivo"/>
-                <a:ea typeface="Archivo"/>
-                <a:cs typeface="Archivo"/>
-              </a:defRPr>
-            </a:pPr>
-            <a:r>
-              <a:rPr sz="2250" b="1">
-                <a:solidFill>
-                  <a:srgbClr val="16130F"/>
-                </a:solidFill>
-                <a:latin typeface="Archivo"/>
-                <a:ea typeface="Archivo"/>
-                <a:cs typeface="Archivo"/>
-              </a:rPr>
-              <a:t>What the cap covers</a:t>
-            </a:r>
-          </a:p>
-        </p:txBody>
-      </p:sp>
-      <p:sp>
-        <p:nvSpPr>
-          <p:cNvPr id="8" name="text-8-7">
-            <a:extLst xmlns:a="http://schemas.openxmlformats.org/drawingml/2006/main">
-              <a:ext uri="{FF2B5EF4-FFF2-40B4-BE49-F238E27FC236}">
-                <a16:creationId xmlns:a16="http://schemas.microsoft.com/office/drawing/2014/main" id="{46F89933-389F-40E7-9E8F-6EB91690C4DD}"/>
-              </a:ext>
-            </a:extLst>
-          </p:cNvPr>
-          <p:cNvSpPr>
-            <a:spLocks xmlns:a="http://schemas.openxmlformats.org/drawingml/2006/main" noGrp="1"/>
-          </p:cNvSpPr>
-          <p:nvPr/>
-        </p:nvSpPr>
-        <p:spPr>
-          <a:xfrm xmlns:a="http://schemas.openxmlformats.org/drawingml/2006/main">
-            <a:off x="685800" y="5267325"/>
-            <a:ext cx="10820400" cy="338138"/>
-          </a:xfrm>
-          <a:prstGeom xmlns:a="http://schemas.openxmlformats.org/drawingml/2006/main" prst="rect">
-            <a:avLst/>
-          </a:prstGeom>
-          <a:noFill xmlns:a="http://schemas.openxmlformats.org/drawingml/2006/main"/>
-          <a:ln xmlns:a="http://schemas.openxmlformats.org/drawingml/2006/main" w="0">
-            <a:noFill/>
-          </a:ln>
-        </p:spPr>
-        <p:txBody>
-          <a:bodyPr xmlns:a="http://schemas.openxmlformats.org/drawingml/2006/main" wrap="none" lIns="0" tIns="0" rIns="0" bIns="0" anchor="t">
-            <a:noAutofit/>
-          </a:bodyPr>
-          <a:lstStyle xmlns:a="http://schemas.openxmlformats.org/drawingml/2006/main"/>
-          <a:p xmlns:a="http://schemas.openxmlformats.org/drawingml/2006/main">
-            <a:pPr>
-              <a:defRPr sz="1875" b="0">
-                <a:solidFill>
-                  <a:srgbClr val="16130F"/>
-                </a:solidFill>
-                <a:latin typeface="IBM Plex Sans"/>
-                <a:ea typeface="IBM Plex Sans"/>
-                <a:cs typeface="IBM Plex Sans"/>
-              </a:defRPr>
-            </a:pPr>
-            <a:r>
-              <a:rPr sz="1875" b="0">
-                <a:solidFill>
-                  <a:srgbClr val="16130F"/>
-                </a:solidFill>
-                <a:latin typeface="IBM Plex Sans"/>
-                <a:ea typeface="IBM Plex Sans"/>
-                <a:cs typeface="IBM Plex Sans"/>
-              </a:rPr>
-              <a:t>The program enforces the recorded sale price. Cash side payments</a:t>
-            </a:r>
-          </a:p>
-        </p:txBody>
-      </p:sp>
-      <p:sp>
-        <p:nvSpPr>
-          <p:cNvPr id="9" name="text-8-8">
-            <a:extLst xmlns:a="http://schemas.openxmlformats.org/drawingml/2006/main">
-              <a:ext uri="{FF2B5EF4-FFF2-40B4-BE49-F238E27FC236}">
-                <a16:creationId xmlns:a16="http://schemas.microsoft.com/office/drawing/2014/main" id="{82D186A0-FAB1-4B4D-A1DE-88DF708812AA}"/>
-              </a:ext>
-            </a:extLst>
-          </p:cNvPr>
-          <p:cNvSpPr>
-            <a:spLocks xmlns:a="http://schemas.openxmlformats.org/drawingml/2006/main" noGrp="1"/>
-          </p:cNvSpPr>
-          <p:nvPr/>
-        </p:nvSpPr>
-        <p:spPr>
-          <a:xfrm xmlns:a="http://schemas.openxmlformats.org/drawingml/2006/main">
-            <a:off x="685800" y="5572125"/>
-            <a:ext cx="10820400" cy="338138"/>
-          </a:xfrm>
-          <a:prstGeom xmlns:a="http://schemas.openxmlformats.org/drawingml/2006/main" prst="rect">
-            <a:avLst/>
-          </a:prstGeom>
-          <a:noFill xmlns:a="http://schemas.openxmlformats.org/drawingml/2006/main"/>
-          <a:ln xmlns:a="http://schemas.openxmlformats.org/drawingml/2006/main" w="0">
-            <a:noFill/>
-          </a:ln>
-        </p:spPr>
-        <p:txBody>
-          <a:bodyPr xmlns:a="http://schemas.openxmlformats.org/drawingml/2006/main" wrap="none" lIns="0" tIns="0" rIns="0" bIns="0" anchor="t">
-            <a:noAutofit/>
-          </a:bodyPr>
-          <a:lstStyle xmlns:a="http://schemas.openxmlformats.org/drawingml/2006/main"/>
-          <a:p xmlns:a="http://schemas.openxmlformats.org/drawingml/2006/main">
-            <a:pPr>
-              <a:defRPr sz="1875" b="0">
-                <a:solidFill>
-                  <a:srgbClr val="16130F"/>
-                </a:solidFill>
-                <a:latin typeface="IBM Plex Sans"/>
-                <a:ea typeface="IBM Plex Sans"/>
-                <a:cs typeface="IBM Plex Sans"/>
-              </a:defRPr>
-            </a:pPr>
-            <a:r>
-              <a:rPr sz="1875" b="0">
-                <a:solidFill>
-                  <a:srgbClr val="16130F"/>
-                </a:solidFill>
-                <a:latin typeface="IBM Plex Sans"/>
-                <a:ea typeface="IBM Plex Sans"/>
-                <a:cs typeface="IBM Plex Sans"/>
-              </a:rPr>
-              <a:t>and wallet sharing remain possible. This demo uses test credits.</a:t>
-            </a:r>
-          </a:p>
-        </p:txBody>
-      </p:sp>
-      <p:sp>
-        <p:nvSpPr>
-          <p:cNvPr id="10" name="text-8-9">
-            <a:extLst xmlns:a="http://schemas.openxmlformats.org/drawingml/2006/main">
-              <a:ext uri="{FF2B5EF4-FFF2-40B4-BE49-F238E27FC236}">
-                <a16:creationId xmlns:a16="http://schemas.microsoft.com/office/drawing/2014/main" id="{556CC786-BBB7-44C2-B238-0598349EB644}"/>
-              </a:ext>
-            </a:extLst>
-          </p:cNvPr>
-          <p:cNvSpPr>
-            <a:spLocks xmlns:a="http://schemas.openxmlformats.org/drawingml/2006/main" noGrp="1"/>
-          </p:cNvSpPr>
-          <p:nvPr/>
-        </p:nvSpPr>
-        <p:spPr>
-          <a:xfrm xmlns:a="http://schemas.openxmlformats.org/drawingml/2006/main">
-            <a:off x="685800" y="5876925"/>
-            <a:ext cx="10820400" cy="338138"/>
-          </a:xfrm>
-          <a:prstGeom xmlns:a="http://schemas.openxmlformats.org/drawingml/2006/main" prst="rect">
-            <a:avLst/>
-          </a:prstGeom>
-          <a:noFill xmlns:a="http://schemas.openxmlformats.org/drawingml/2006/main"/>
-          <a:ln xmlns:a="http://schemas.openxmlformats.org/drawingml/2006/main" w="0">
-            <a:noFill/>
-          </a:ln>
-        </p:spPr>
-        <p:txBody>
-          <a:bodyPr xmlns:a="http://schemas.openxmlformats.org/drawingml/2006/main" wrap="none" lIns="0" tIns="0" rIns="0" bIns="0" anchor="t">
-            <a:noAutofit/>
-          </a:bodyPr>
-          <a:lstStyle xmlns:a="http://schemas.openxmlformats.org/drawingml/2006/main"/>
-          <a:p xmlns:a="http://schemas.openxmlformats.org/drawingml/2006/main">
-            <a:pPr>
-              <a:defRPr sz="1875" b="0">
-                <a:solidFill>
-                  <a:srgbClr val="16130F"/>
-                </a:solidFill>
-                <a:latin typeface="IBM Plex Sans"/>
-                <a:ea typeface="IBM Plex Sans"/>
-                <a:cs typeface="IBM Plex Sans"/>
-              </a:defRPr>
-            </a:pPr>
-            <a:r>
-              <a:rPr sz="1875" b="0">
-                <a:solidFill>
-                  <a:srgbClr val="16130F"/>
-                </a:solidFill>
-                <a:latin typeface="IBM Plex Sans"/>
-                <a:ea typeface="IBM Plex Sans"/>
-                <a:cs typeface="IBM Plex Sans"/>
-              </a:rPr>
-              <a:t>Euro checkout, check-in and security review are still pending.</a:t>
-            </a:r>
-          </a:p>
-        </p:txBody>
-      </p:sp>
-      <p:sp>
-        <p:nvSpPr>
-          <p:cNvPr id="11" name="text-8-10">
-            <a:extLst xmlns:a="http://schemas.openxmlformats.org/drawingml/2006/main">
-              <a:ext uri="{FF2B5EF4-FFF2-40B4-BE49-F238E27FC236}">
-                <a16:creationId xmlns:a16="http://schemas.microsoft.com/office/drawing/2014/main" id="{0C66B2CD-129F-4E11-B6E1-0DFD69BD08E3}"/>
-              </a:ext>
-            </a:extLst>
-          </p:cNvPr>
-          <p:cNvSpPr>
-            <a:spLocks xmlns:a="http://schemas.openxmlformats.org/drawingml/2006/main" noGrp="1"/>
-          </p:cNvSpPr>
-          <p:nvPr/>
-        </p:nvSpPr>
-        <p:spPr>
-          <a:xfrm xmlns:a="http://schemas.openxmlformats.org/drawingml/2006/main">
-            <a:off x="685800" y="6334125"/>
-            <a:ext cx="10096500" cy="270510"/>
-          </a:xfrm>
-          <a:prstGeom xmlns:a="http://schemas.openxmlformats.org/drawingml/2006/main" prst="rect">
-            <a:avLst/>
-          </a:prstGeom>
-          <a:noFill xmlns:a="http://schemas.openxmlformats.org/drawingml/2006/main"/>
-          <a:ln xmlns:a="http://schemas.openxmlformats.org/drawingml/2006/main" w="0">
-            <a:noFill/>
-          </a:ln>
-        </p:spPr>
-        <p:txBody>
-          <a:bodyPr xmlns:a="http://schemas.openxmlformats.org/drawingml/2006/main" wrap="none" lIns="0" tIns="0" rIns="0" bIns="0" anchor="t">
-            <a:noAutofit/>
-          </a:bodyPr>
-          <a:lstStyle xmlns:a="http://schemas.openxmlformats.org/drawingml/2006/main"/>
-          <a:p xmlns:a="http://schemas.openxmlformats.org/drawingml/2006/main">
-            <a:pPr>
-              <a:defRPr sz="1500" b="0">
-                <a:solidFill>
-                  <a:srgbClr val="16130F"/>
-                </a:solidFill>
-                <a:latin typeface="IBM Plex Sans"/>
-                <a:ea typeface="IBM Plex Sans"/>
-                <a:cs typeface="IBM Plex Sans"/>
-              </a:defRPr>
-            </a:pPr>
-            <a:r>
-              <a:rPr sz="1500" b="0">
-                <a:solidFill>
-                  <a:srgbClr val="16130F"/>
-                </a:solidFill>
-                <a:latin typeface="IBM Plex Sans"/>
-                <a:ea typeface="IBM Plex Sans"/>
-                <a:cs typeface="IBM Plex Sans"/>
-              </a:rPr>
-              <a:t>Development upgrade authority remains active.</a:t>
             </a:r>
           </a:p>
         </p:txBody>
@@ -7093,7 +6466,7 @@
     </p:spTree>
     <p:extLst>
       <p:ext uri="{BB962C8B-B14F-4D97-AF65-F5344CB8AC3E}">
-        <p14:creationId xmlns:p14="http://schemas.microsoft.com/office/powerpoint/2010/main" val="286135213"/>
+        <p14:creationId xmlns:p14="http://schemas.microsoft.com/office/powerpoint/2010/main" val="1380779087"/>
       </p:ext>
     </p:extLst>
   </p:cSld>

</xml_diff>